<commit_message>
BD II: guion por lamina en las notas, ideas escritas, pasos logicos e ilustraciones en todas las clases; SQL verificado en PGlite
Co-Authored-By: Claude Opus 5.5 <noreply@anthropic.com>
</commit_message>
<xml_diff>
--- a/Bases de Datos II/Clases/Clase 11 - Avance del proyecto final/Presentacion.pptx
+++ b/Bases de Datos II/Clases/Clase 11 - Avance del proyecto final/Presentacion.pptx
@@ -516,47 +516,648 @@
           <a:lstStyle/>
           <a:p>
             <a:r>
-              <a:t>DESARROLLO (para explicarlo, no se proyecta):</a:t>
-            </a:r>
-          </a:p>
-          <a:p>
-            <a:r>
-              <a:t>Una revision tecnica es una reunion con un proposito unico: encontrar defectos en un artefacto antes de que cuesten caro, y salir con un producto escrito.</a:t>
-            </a:r>
-          </a:p>
-          <a:p>
-            <a:r>
-              <a:t>No es una reunion de avance, no es una calificacion y no es una demostracion para lucirse.</a:t>
-            </a:r>
-          </a:p>
-          <a:p>
-            <a:r>
-              <a:t>La practica tiene nombres y roles establecidos desde hace decadas en ingenieria de software: el autor presenta, uno o mas revisores buscan defectos, un moderador cuida el tiempo y el tono, y un escriba registra los hallazgos.</a:t>
-            </a:r>
-          </a:p>
-          <a:p>
-            <a:r>
-              <a:t>El estandar clasico, IEEE 1028, distingue la inspeccion (formal, con lista de verificacion y metricas), el walkthrough (el autor guia y explica) y la revision tecnica propiamente dicha (los pares evaluan si el artefacto sirve para su proposito).</a:t>
-            </a:r>
-          </a:p>
-          <a:p>
-            <a:r>
-              <a:t>NOTAS:</a:t>
-            </a:r>
-          </a:p>
-          <a:p>
-            <a:r>
-              <a:t>Lo que se hace hoy es una revision tecnica con lista de verificacion, comprimida a diez minutos por estudiante.</a:t>
-            </a:r>
-          </a:p>
-          <a:p>
-            <a:r>
-              <a:t>Dos reglas gobiernan la sesion y hay que decirlas en voz alta antes de empezar: se revisa el artefacto y no la persona, y no se resuelve el problema dentro de la revision, solo se registra.</a:t>
-            </a:r>
-          </a:p>
-          <a:p>
-            <a:r>
-              <a:t>Un estudiante que se pone a corregir el DDL en vivo consume el tiempo de los demas y sale con un hallazgo menos que si hubiera seguido escuchando.</a:t>
+              <a:t>QUÉ ES (dilo así): Una revisión técnica es una reunión con un solo propósito: encontrar defectos en un producto de trabajo mientras todavía es barato corregirlos, y salir con una lista escrita. No es una reunión de avance, ni una calificación, ni una demostración para lucirse.</a:t>
+            </a:r>
+          </a:p>
+          <a:p/>
+          <a:p>
+            <a:r>
+              <a:t>CÓMO DARLA (≈5 min):</a:t>
+            </a:r>
+          </a:p>
+          <a:p>
+            <a:r>
+              <a:t>  • Al entrar: El objetivo arriba y el artefacto al centro: puede ser el ER, el script DDL, la matriz de roles o un procedimiento. Todo gira alrededor del producto, no de quien lo hizo.</a:t>
+            </a:r>
+          </a:p>
+          <a:p>
+            <a:r>
+              <a:t>  • Clic 1: Los cuatro roles: el autor presenta y responde, los revisores buscan defectos, el moderador cuida tiempo y tono, el escriba anota cada hallazgo. Entre dos personas, una hace de autor y la otra de revisor y escriba.</a:t>
+            </a:r>
+          </a:p>
+          <a:p>
+            <a:r>
+              <a:t>  • Clic 2: El producto es el acta de hallazgos. Si de la reunión no sale nada escrito, no hubo revisión: hubo conversación.</a:t>
+            </a:r>
+          </a:p>
+          <a:p>
+            <a:r>
+              <a:t>  • Clic 3: Las dos reglas, dichas antes de empezar: se revisa el artefacto y no la persona, y el problema no se arregla dentro de la revisión. Quien se pone a corregir el DDL en vivo consume el tiempo de todos.</a:t>
+            </a:r>
+          </a:p>
+          <a:p/>
+          <a:p>
+            <a:r>
+              <a:t>EJEMPLO: El estándar IEEE 1028 distingue la inspección (formal, con lista de verificación y métricas), el walkthrough (el autor guía) y la revisión técnica (los pares evalúan si el artefacto sirve). Hoy se hace una revisión técnica con lista de verificación, de unos diez minutos por persona.</a:t>
+            </a:r>
+          </a:p>
+          <a:p/>
+          <a:p>
+            <a:r>
+              <a:t>SI PREGUNTAN:</a:t>
+            </a:r>
+          </a:p>
+          <a:p>
+            <a:r>
+              <a:t>  • «¿Esto tiene nota?» → La revisión no califica el producto: es la última oportunidad de mover puntos antes de la entrega. Conviene llegar con lo más flojo, no con lo mejor.</a:t>
+            </a:r>
+          </a:p>
+          <a:p>
+            <a:r>
+              <a:t>  • «¿Si el revisor encuentra fallas me bajan la nota?» → No: el revisor par no califica. Encontrar fallas es el objetivo de la sesión.</a:t>
+            </a:r>
+          </a:p>
+          <a:p/>
+          <a:p>
+            <a:r>
+              <a:t>CUIDADO: El error típico del docente es convertir la revisión en «va bien, faltan detalles»: amable, global y sin nada escrito. Sin acta, los defectos llegan intactos a la entrega final.</a:t>
+            </a:r>
+          </a:p>
+          <a:p/>
+          <a:p>
+            <a:r>
+              <a:t>PASA A LA SIGUIENTE: ¿Qué se revisa en una base de datos? No cada pieza: la coherencia entre ellas.</a:t>
+            </a:r>
+          </a:p>
+        </p:txBody>
+      </p:sp>
+      <p:sp>
+        <p:nvSpPr>
+          <p:cNvPr id="4" name="Slide Number Placeholder 3"/>
+          <p:cNvSpPr>
+            <a:spLocks noGrp="1"/>
+          </p:cNvSpPr>
+          <p:nvPr>
+            <p:ph type="sldNum" idx="5" sz="quarter"/>
+          </p:nvPr>
+        </p:nvSpPr>
+        <p:spPr/>
+      </p:sp>
+    </p:spTree>
+  </p:cSld>
+  <p:clrMapOvr>
+    <a:masterClrMapping/>
+  </p:clrMapOvr>
+</p:notes>
+</file>
+
+<file path=ppt/notesSlides/notesSlide10.xml><?xml version="1.0" encoding="utf-8"?>
+<p:notes xmlns:a="http://schemas.openxmlformats.org/drawingml/2006/main" xmlns:p="http://schemas.openxmlformats.org/presentationml/2006/main" xmlns:r="http://schemas.openxmlformats.org/officeDocument/2006/relationships">
+  <p:cSld>
+    <p:spTree>
+      <p:nvGrpSpPr>
+        <p:cNvPr id="1" name=""/>
+        <p:cNvGrpSpPr/>
+        <p:nvPr/>
+      </p:nvGrpSpPr>
+      <p:grpSpPr>
+        <a:xfrm>
+          <a:off x="0" y="0"/>
+          <a:ext cx="0" cy="0"/>
+          <a:chOff x="0" y="0"/>
+          <a:chExt cx="0" cy="0"/>
+        </a:xfrm>
+      </p:grpSpPr>
+      <p:sp>
+        <p:nvSpPr>
+          <p:cNvPr id="2" name="Slide Image Placeholder 1"/>
+          <p:cNvSpPr>
+            <a:spLocks noGrp="1"/>
+          </p:cNvSpPr>
+          <p:nvPr>
+            <p:ph type="sldImg" idx="2"/>
+          </p:nvPr>
+        </p:nvSpPr>
+        <p:spPr/>
+      </p:sp>
+      <p:sp>
+        <p:nvSpPr>
+          <p:cNvPr id="3" name="Notes Placeholder 2"/>
+          <p:cNvSpPr>
+            <a:spLocks noGrp="1"/>
+          </p:cNvSpPr>
+          <p:nvPr>
+            <p:ph type="body" idx="3" sz="quarter"/>
+          </p:nvPr>
+        </p:nvSpPr>
+        <p:spPr/>
+        <p:txBody>
+          <a:bodyPr/>
+          <a:lstStyle/>
+          <a:p>
+            <a:r>
+              <a:t>QUÉ ES (dilo así): El catálogo de la base, information_schema, responde con datos qué tablas existen y cuáles tienen clave primaria. Así se verifica el DDL sin leerlo línea por línea.</a:t>
+            </a:r>
+          </a:p>
+          <a:p/>
+          <a:p>
+            <a:r>
+              <a:t>CÓMO DARLA (≈4 min):</a:t>
+            </a:r>
+          </a:p>
+          <a:p>
+            <a:r>
+              <a:t>  • Líneas 1-3: Lista las tablas del esquema public en orden alfabético. En una base con el modelo completo y la auditoría aparecen 9: audit_cita, cita, consulta, detalle_factura, dueno, factura, insumo, mascota y veterinario. Cualquier otra es una tabla sin entidad que revisar.</a:t>
+            </a:r>
+          </a:p>
+          <a:p>
+            <a:r>
+              <a:t>  • Líneas 5-10: Une cada tabla con sus restricciones PRIMARY KEY mediante LEFT JOIN y se queda con las que no encontraron ninguna (c.constraint_name IS NULL).</a:t>
+            </a:r>
+          </a:p>
+          <a:p>
+            <a:r>
+              <a:t>  • Línea 11: Cero filas significa que todas las tablas tienen clave primaria. Cada fila que aparezca es un hallazgo.</a:t>
+            </a:r>
+          </a:p>
+          <a:p/>
+          <a:p>
+            <a:r>
+              <a:t>EJEMPLO: En la base completa del curso la segunda consulta devuelve 0 filas: todas las tablas, incluida audit_cita, tienen su clave primaria.</a:t>
+            </a:r>
+          </a:p>
+          <a:p/>
+          <a:p>
+            <a:r>
+              <a:t>SI PREGUNTAN:</a:t>
+            </a:r>
+          </a:p>
+          <a:p>
+            <a:r>
+              <a:t>  • «¿Por qué LEFT JOIN y no JOIN?» → Porque se buscan las tablas que NO tienen PK: un JOIN las descartaría; el LEFT JOIN las conserva con NULL en las columnas de la restricción, y el WHERE … IS NULL las deja solas.</a:t>
+            </a:r>
+          </a:p>
+          <a:p>
+            <a:r>
+              <a:t>  • «¿information_schema es de PostgreSQL?» → Es del estándar SQL: también existe en MySQL y SQL Server. PostgreSQL tiene además su catálogo propio, pg_catalog.</a:t>
+            </a:r>
+          </a:p>
+          <a:p/>
+          <a:p>
+            <a:r>
+              <a:t>CUIDADO: Corre las consultas sobre la base que el autor va a entregar, no sobre una copia de prueba: el catálogo describe la base en la que se ejecuta.</a:t>
+            </a:r>
+          </a:p>
+          <a:p/>
+          <a:p>
+            <a:r>
+              <a:t>PASA A LA SIGUIENTE: Una revisión también encuentra lo contrario de lo que falta: lo que sobra.</a:t>
+            </a:r>
+          </a:p>
+        </p:txBody>
+      </p:sp>
+      <p:sp>
+        <p:nvSpPr>
+          <p:cNvPr id="4" name="Slide Number Placeholder 3"/>
+          <p:cNvSpPr>
+            <a:spLocks noGrp="1"/>
+          </p:cNvSpPr>
+          <p:nvPr>
+            <p:ph type="sldNum" idx="5" sz="quarter"/>
+          </p:nvPr>
+        </p:nvSpPr>
+        <p:spPr/>
+      </p:sp>
+    </p:spTree>
+  </p:cSld>
+  <p:clrMapOvr>
+    <a:masterClrMapping/>
+  </p:clrMapOvr>
+</p:notes>
+</file>
+
+<file path=ppt/notesSlides/notesSlide11.xml><?xml version="1.0" encoding="utf-8"?>
+<p:notes xmlns:a="http://schemas.openxmlformats.org/drawingml/2006/main" xmlns:p="http://schemas.openxmlformats.org/presentationml/2006/main" xmlns:r="http://schemas.openxmlformats.org/officeDocument/2006/relationships">
+  <p:cSld>
+    <p:spTree>
+      <p:nvGrpSpPr>
+        <p:cNvPr id="1" name=""/>
+        <p:cNvGrpSpPr/>
+        <p:nvPr/>
+      </p:nvGrpSpPr>
+      <p:grpSpPr>
+        <a:xfrm>
+          <a:off x="0" y="0"/>
+          <a:ext cx="0" cy="0"/>
+          <a:chOff x="0" y="0"/>
+          <a:chExt cx="0" cy="0"/>
+        </a:xfrm>
+      </p:grpSpPr>
+      <p:sp>
+        <p:nvSpPr>
+          <p:cNvPr id="2" name="Slide Image Placeholder 1"/>
+          <p:cNvSpPr>
+            <a:spLocks noGrp="1"/>
+          </p:cNvSpPr>
+          <p:nvPr>
+            <p:ph type="sldImg" idx="2"/>
+          </p:nvPr>
+        </p:nvSpPr>
+        <p:spPr/>
+      </p:sp>
+      <p:sp>
+        <p:nvSpPr>
+          <p:cNvPr id="3" name="Notes Placeholder 2"/>
+          <p:cNvSpPr>
+            <a:spLocks noGrp="1"/>
+          </p:cNvSpPr>
+          <p:nvPr>
+            <p:ph type="body" idx="3" sz="quarter"/>
+          </p:nvPr>
+        </p:nvSpPr>
+        <p:spPr/>
+        <p:txBody>
+          <a:bodyPr/>
+          <a:lstStyle/>
+          <a:p>
+            <a:r>
+              <a:t>QUÉ ES (dilo así): Dos verificaciones más con el catálogo: qué claves foráneas existen y qué procedimientos, funciones y triggers hay de verdad en la base, no en el informe.</a:t>
+            </a:r>
+          </a:p>
+          <a:p/>
+          <a:p>
+            <a:r>
+              <a:t>CÓMO DARLA (≈4 min):</a:t>
+            </a:r>
+          </a:p>
+          <a:p>
+            <a:r>
+              <a:t>  • Líneas 1-9: Une las restricciones FOREIGN KEY con la columna que las lleva (key_column_usage) y con la tabla a la que apuntan (constraint_column_usage). En la base completa devuelve 7 filas: cita→veterinario, cita→mascota, consulta→cita, detalle_factura→factura, detalle_factura→insumo, factura→consulta y mascota→dueno.</a:t>
+            </a:r>
+          </a:p>
+          <a:p>
+            <a:r>
+              <a:t>  • Líneas 11-13: information_schema.routines lista lo que existe con su tipo: con el avance completo aparecen fn_trg_audit_cita (FUNCTION), sp_agendar_cita y sp_facturar (PROCEDURE).</a:t>
+            </a:r>
+          </a:p>
+          <a:p>
+            <a:r>
+              <a:t>  • Línea 14: information_schema.triggers devuelve trg_audit_cita sobre cita. Un trigger aparece una vez por cada evento que lo dispara; este solo escucha UPDATE.</a:t>
+            </a:r>
+          </a:p>
+          <a:p/>
+          <a:p>
+            <a:r>
+              <a:t>EJEMPLO: Si el informe dice «tres procedimientos» y routines devuelve dos, el tercero está en un archivo y no en la base: hallazgo.</a:t>
+            </a:r>
+          </a:p>
+          <a:p/>
+          <a:p>
+            <a:r>
+              <a:t>SI PREGUNTAN:</a:t>
+            </a:r>
+          </a:p>
+          <a:p>
+            <a:r>
+              <a:t>  • «¿Por qué la función del trigger aparece como FUNCTION?» → Porque en PostgreSQL el trigger son dos objetos: la función RETURNS TRIGGER, que es una rutina más, y la asociación CREATE TRIGGER, que está en information_schema.triggers.</a:t>
+            </a:r>
+          </a:p>
+          <a:p/>
+          <a:p>
+            <a:r>
+              <a:t>CUIDADO: La consulta de claves foráneas une solo por nombre de restricción: una FK de dos columnas aparecería repetida. En el modelo del curso todas son de una columna.</a:t>
+            </a:r>
+          </a:p>
+          <a:p/>
+          <a:p>
+            <a:r>
+              <a:t>PASA A LA SIGUIENTE: Ahora todo esto en la demo.</a:t>
+            </a:r>
+          </a:p>
+        </p:txBody>
+      </p:sp>
+      <p:sp>
+        <p:nvSpPr>
+          <p:cNvPr id="4" name="Slide Number Placeholder 3"/>
+          <p:cNvSpPr>
+            <a:spLocks noGrp="1"/>
+          </p:cNvSpPr>
+          <p:nvPr>
+            <p:ph type="sldNum" idx="5" sz="quarter"/>
+          </p:nvPr>
+        </p:nvSpPr>
+        <p:spPr/>
+      </p:sp>
+    </p:spTree>
+  </p:cSld>
+  <p:clrMapOvr>
+    <a:masterClrMapping/>
+  </p:clrMapOvr>
+</p:notes>
+</file>
+
+<file path=ppt/notesSlides/notesSlide12.xml><?xml version="1.0" encoding="utf-8"?>
+<p:notes xmlns:a="http://schemas.openxmlformats.org/drawingml/2006/main" xmlns:p="http://schemas.openxmlformats.org/presentationml/2006/main" xmlns:r="http://schemas.openxmlformats.org/officeDocument/2006/relationships">
+  <p:cSld>
+    <p:spTree>
+      <p:nvGrpSpPr>
+        <p:cNvPr id="1" name=""/>
+        <p:cNvGrpSpPr/>
+        <p:nvPr/>
+      </p:nvGrpSpPr>
+      <p:grpSpPr>
+        <a:xfrm>
+          <a:off x="0" y="0"/>
+          <a:ext cx="0" cy="0"/>
+          <a:chOff x="0" y="0"/>
+          <a:chExt cx="0" cy="0"/>
+        </a:xfrm>
+      </p:grpSpPr>
+      <p:sp>
+        <p:nvSpPr>
+          <p:cNvPr id="2" name="Slide Image Placeholder 1"/>
+          <p:cNvSpPr>
+            <a:spLocks noGrp="1"/>
+          </p:cNvSpPr>
+          <p:nvPr>
+            <p:ph type="sldImg" idx="2"/>
+          </p:nvPr>
+        </p:nvSpPr>
+        <p:spPr/>
+      </p:sp>
+      <p:sp>
+        <p:nvSpPr>
+          <p:cNvPr id="3" name="Notes Placeholder 2"/>
+          <p:cNvSpPr>
+            <a:spLocks noGrp="1"/>
+          </p:cNvSpPr>
+          <p:nvPr>
+            <p:ph type="body" idx="3" sz="quarter"/>
+          </p:nvPr>
+        </p:nvSpPr>
+        <p:spPr/>
+        <p:txBody>
+          <a:bodyPr/>
+          <a:lstStyle/>
+          <a:p>
+            <a:r>
+              <a:t>QUÉ ES (dilo así): La demo es una revisión real de diez minutos sobre una base completa: el docente hace de revisor, ejecuta las verificaciones y escribe los hallazgos en vivo con sus cinco partes.</a:t>
+            </a:r>
+          </a:p>
+          <a:p/>
+          <a:p>
+            <a:r>
+              <a:t>CÓMO DARLA (≈15 min):</a:t>
+            </a:r>
+          </a:p>
+          <a:p>
+            <a:r>
+              <a:t>  • 1 · Catálogo: Ejecuta las consultas de las dos láminas de código: tablas, tablas sin PK (0 filas), claves foráneas (7) y rutinas y triggers. Compara cada resultado con el ER.</a:t>
+            </a:r>
+          </a:p>
+          <a:p>
+            <a:r>
+              <a:t>  • 2 · Procedimiento: CALL sp_agendar_cita(1, 2, TIMESTAMP '2026-11-05 10:00:00') inserta; CALL sp_agendar_cita(3, 2, TIMESTAMP '2026-11-05 09:00:00') responde «ERROR: la mascota 3 esta inactiva; no se agenda cita». Muestra SELECT COUNT(*) FROM cita antes y después de la segunda.</a:t>
+            </a:r>
+          </a:p>
+          <a:p>
+            <a:r>
+              <a:t>  • 3 · Hallazgo: Escribe un hallazgo completo en el acta, en voz alta, parte por parte. Si la base no tiene ninguno real, usa el de detalle_factura sin FK y pruébalo con el INSERT del insumo 999.</a:t>
+            </a:r>
+          </a:p>
+          <a:p>
+            <a:r>
+              <a:t>  • 4 · Cierre: Muestra el acta terminada: de 3 a 5 hallazgos, cada uno con responsable y fecha.</a:t>
+            </a:r>
+          </a:p>
+          <a:p/>
+          <a:p>
+            <a:r>
+              <a:t>EJEMPLO: Tiempos sugeridos: catálogo 5 min, procedimiento 4 min, hallazgo 4 min, cierre 2 min.</a:t>
+            </a:r>
+          </a:p>
+          <a:p/>
+          <a:p>
+            <a:r>
+              <a:t>SI PREGUNTAN:</a:t>
+            </a:r>
+          </a:p>
+          <a:p>
+            <a:r>
+              <a:t>  • «¿Y si la base del estudiante no corre?» → Ese es el primer hallazgo, y el más grave: sin un script que corra de principio a fin en una base vacía no hay sobre qué montar lo demás.</a:t>
+            </a:r>
+          </a:p>
+          <a:p/>
+          <a:p>
+            <a:r>
+              <a:t>CUIDADO: No corrijas en vivo lo que encuentres: anótalo. Corregir dentro de la revisión es la regla que más se rompe.</a:t>
+            </a:r>
+          </a:p>
+          <a:p/>
+          <a:p>
+            <a:r>
+              <a:t>PASA A LA SIGUIENTE: Para el ER del avance: del boceto al código Mermaid.</a:t>
+            </a:r>
+          </a:p>
+        </p:txBody>
+      </p:sp>
+      <p:sp>
+        <p:nvSpPr>
+          <p:cNvPr id="4" name="Slide Number Placeholder 3"/>
+          <p:cNvSpPr>
+            <a:spLocks noGrp="1"/>
+          </p:cNvSpPr>
+          <p:nvPr>
+            <p:ph type="sldNum" idx="5" sz="quarter"/>
+          </p:nvPr>
+        </p:nvSpPr>
+        <p:spPr/>
+      </p:sp>
+    </p:spTree>
+  </p:cSld>
+  <p:clrMapOvr>
+    <a:masterClrMapping/>
+  </p:clrMapOvr>
+</p:notes>
+</file>
+
+<file path=ppt/notesSlides/notesSlide13.xml><?xml version="1.0" encoding="utf-8"?>
+<p:notes xmlns:a="http://schemas.openxmlformats.org/drawingml/2006/main" xmlns:p="http://schemas.openxmlformats.org/presentationml/2006/main" xmlns:r="http://schemas.openxmlformats.org/officeDocument/2006/relationships">
+  <p:cSld>
+    <p:spTree>
+      <p:nvGrpSpPr>
+        <p:cNvPr id="1" name=""/>
+        <p:cNvGrpSpPr/>
+        <p:nvPr/>
+      </p:nvGrpSpPr>
+      <p:grpSpPr>
+        <a:xfrm>
+          <a:off x="0" y="0"/>
+          <a:ext cx="0" cy="0"/>
+          <a:chOff x="0" y="0"/>
+          <a:chExt cx="0" cy="0"/>
+        </a:xfrm>
+      </p:grpSpPr>
+      <p:sp>
+        <p:nvSpPr>
+          <p:cNvPr id="2" name="Slide Image Placeholder 1"/>
+          <p:cNvSpPr>
+            <a:spLocks noGrp="1"/>
+          </p:cNvSpPr>
+          <p:nvPr>
+            <p:ph type="sldImg" idx="2"/>
+          </p:nvPr>
+        </p:nvSpPr>
+        <p:spPr/>
+      </p:sp>
+      <p:sp>
+        <p:nvSpPr>
+          <p:cNvPr id="3" name="Notes Placeholder 2"/>
+          <p:cNvSpPr>
+            <a:spLocks noGrp="1"/>
+          </p:cNvSpPr>
+          <p:nvPr>
+            <p:ph type="body" idx="3" sz="quarter"/>
+          </p:nvPr>
+        </p:nvSpPr>
+        <p:spPr/>
+        <p:txBody>
+          <a:bodyPr/>
+          <a:lstStyle/>
+          <a:p>
+            <a:r>
+              <a:t>QUÉ ES (dilo así): El diagrama se entrega como texto Mermaid, no como imagen: la imagen sale del código. Se piensa dibujando, se traduce a texto, se comprueba que dibuje y se guardan las dos cosas.</a:t>
+            </a:r>
+          </a:p>
+          <a:p/>
+          <a:p>
+            <a:r>
+              <a:t>CÓMO DARLA (≈3 min):</a:t>
+            </a:r>
+          </a:p>
+          <a:p>
+            <a:r>
+              <a:t>  • Paso 1: Diseña visual: en Excalidraw o draw.io arrastrar cajas es más rápido, y ahí se piensa el modelo.</a:t>
+            </a:r>
+          </a:p>
+          <a:p>
+            <a:r>
+              <a:t>  • Paso 2: Traduce con IA: pide el código erDiagram a partir del boceto. Revisa el resultado: la IA acierta la sintaxis, no el modelo; los nombres tienen que ser los del DDL.</a:t>
+            </a:r>
+          </a:p>
+          <a:p>
+            <a:r>
+              <a:t>  • Paso 3: Renderiza y corrige en un visor Mermaid (mermaid.live): si no dibuja, no comunica.</a:t>
+            </a:r>
+          </a:p>
+          <a:p>
+            <a:r>
+              <a:t>  • Paso 4: Guarda el texto Mermaid, que es la fuente, y exporta el PNG.</a:t>
+            </a:r>
+          </a:p>
+          <a:p/>
+          <a:p>
+            <a:r>
+              <a:t>EJEMPLO: Una relación en erDiagram: dueno ||--o{ mascota : tiene (un dueño, cero o muchas mascotas). Cada entidad lleva sus atributos con tipo y PK o FK: int id_mascota PK.</a:t>
+            </a:r>
+          </a:p>
+          <a:p/>
+          <a:p>
+            <a:r>
+              <a:t>SI PREGUNTAN:</a:t>
+            </a:r>
+          </a:p>
+          <a:p>
+            <a:r>
+              <a:t>  • «¿Por qué no basta una imagen del diagrama?» → Porque el texto se puede revisar, comparar con el DDL y versionar; una imagen no se corrige sin volver a dibujarla.</a:t>
+            </a:r>
+          </a:p>
+          <a:p/>
+          <a:p>
+            <a:r>
+              <a:t>CUIDADO: Revisa que los nombres del erDiagram sean exactamente los del DDL (dueno, no Dueño): un diagrama que no coincide con el script es justo el hallazgo de coherencia de hoy.</a:t>
+            </a:r>
+          </a:p>
+          <a:p/>
+          <a:p>
+            <a:r>
+              <a:t>PASA A LA SIGUIENTE: Cierre de la clase.</a:t>
+            </a:r>
+          </a:p>
+        </p:txBody>
+      </p:sp>
+      <p:sp>
+        <p:nvSpPr>
+          <p:cNvPr id="4" name="Slide Number Placeholder 3"/>
+          <p:cNvSpPr>
+            <a:spLocks noGrp="1"/>
+          </p:cNvSpPr>
+          <p:nvPr>
+            <p:ph type="sldNum" idx="5" sz="quarter"/>
+          </p:nvPr>
+        </p:nvSpPr>
+        <p:spPr/>
+      </p:sp>
+    </p:spTree>
+  </p:cSld>
+  <p:clrMapOvr>
+    <a:masterClrMapping/>
+  </p:clrMapOvr>
+</p:notes>
+</file>
+
+<file path=ppt/notesSlides/notesSlide14.xml><?xml version="1.0" encoding="utf-8"?>
+<p:notes xmlns:a="http://schemas.openxmlformats.org/drawingml/2006/main" xmlns:p="http://schemas.openxmlformats.org/presentationml/2006/main" xmlns:r="http://schemas.openxmlformats.org/officeDocument/2006/relationships">
+  <p:cSld>
+    <p:spTree>
+      <p:nvGrpSpPr>
+        <p:cNvPr id="1" name=""/>
+        <p:cNvGrpSpPr/>
+        <p:nvPr/>
+      </p:nvGrpSpPr>
+      <p:grpSpPr>
+        <a:xfrm>
+          <a:off x="0" y="0"/>
+          <a:ext cx="0" cy="0"/>
+          <a:chOff x="0" y="0"/>
+          <a:chExt cx="0" cy="0"/>
+        </a:xfrm>
+      </p:grpSpPr>
+      <p:sp>
+        <p:nvSpPr>
+          <p:cNvPr id="2" name="Slide Image Placeholder 1"/>
+          <p:cNvSpPr>
+            <a:spLocks noGrp="1"/>
+          </p:cNvSpPr>
+          <p:nvPr>
+            <p:ph type="sldImg" idx="2"/>
+          </p:nvPr>
+        </p:nvSpPr>
+        <p:spPr/>
+      </p:sp>
+      <p:sp>
+        <p:nvSpPr>
+          <p:cNvPr id="3" name="Notes Placeholder 2"/>
+          <p:cNvSpPr>
+            <a:spLocks noGrp="1"/>
+          </p:cNvSpPr>
+          <p:nvPr>
+            <p:ph type="body" idx="3" sz="quarter"/>
+          </p:nvPr>
+        </p:nvSpPr>
+        <p:spPr/>
+        <p:txBody>
+          <a:bodyPr/>
+          <a:lstStyle/>
+          <a:p>
+            <a:r>
+              <a:t>QUÉ ES (dilo así): Cierre: una revisión sirve si sale un acta con hallazgos verificables. Lo que se audita es la coherencia entre piezas, y cada hallazgo se demuestra con una ejecución.</a:t>
+            </a:r>
+          </a:p>
+          <a:p/>
+          <a:p>
+            <a:r>
+              <a:t>CÓMO DARLA (≈3 min):</a:t>
+            </a:r>
+          </a:p>
+          <a:p>
+            <a:r>
+              <a:t>  • Al entrar: Pregunta de salida: «nombra un hallazgo de tu propia base con sus cinco partes». Toma dos respuestas y corrige la que no sea verificable.</a:t>
+            </a:r>
+          </a:p>
+          <a:p>
+            <a:r>
+              <a:t>  • Después: Amarre: la Clase 12, en esta misma sesión, escribe el contrato de operaciones, que solo puede apoyarse en procedimientos que existen y funcionan.</a:t>
             </a:r>
           </a:p>
         </p:txBody>
@@ -626,57 +1227,62 @@
           <a:lstStyle/>
           <a:p>
             <a:r>
-              <a:t>DESARROLLO (para explicarlo, no se proyecta):</a:t>
-            </a:r>
-          </a:p>
-          <a:p>
-            <a:r>
-              <a:t>Un artefacto es cualquier producto de trabajo: el diagrama entidad-relacion, el script DDL, la matriz de roles, los procedimientos, el informe de optimizacion.</a:t>
-            </a:r>
-          </a:p>
-          <a:p>
-            <a:r>
-              <a:t>Es perfectamente posible que un estudiante tenga un ER bien dibujado, un DDL que ejecuta sin errores</a:t>
-            </a:r>
-          </a:p>
-          <a:p>
-            <a:r>
-              <a:t>Y que ambos describan bases de datos distintas, porque el ER se dibujo en la Clase 1 y el DDL se fue parchando en las Clases 3 a 8 sin volver a actualizar el diagrama.</a:t>
-            </a:r>
-          </a:p>
-          <a:p>
-            <a:r>
-              <a:t>Cada una toma dos o tres minutos si se ejecuta con criterio.</a:t>
-            </a:r>
-          </a:p>
-          <a:p>
-            <a:r>
-              <a:t>NOTAS:</a:t>
-            </a:r>
-          </a:p>
-          <a:p>
-            <a:r>
-              <a:t>Lo que se audita en una base de datos no es cada pieza por separado sino la coherencia entre piezas.</a:t>
-            </a:r>
-          </a:p>
-          <a:p>
-            <a:r>
-              <a:t>Coherencia significa que todas esas piezas describen el mismo sistema.</a:t>
-            </a:r>
-          </a:p>
-          <a:p>
-            <a:r>
-              <a:t>Esa divergencia es el hallazgo mas comun del checkpoint y tambien el mas facil de detectar si se sabe donde mirar.</a:t>
-            </a:r>
-          </a:p>
-          <a:p>
-            <a:r>
-              <a:t>Las cuatro verificaciones cruzadas que el docente debe correr son: que el DDL corresponda al ER, que los GRANT correspondan a los roles declarados, que los procedimientos listados existan y sean invocables, y que la optimizacion tenga medicion antes y despues.</a:t>
-            </a:r>
-          </a:p>
-          <a:p>
-            <a:r>
-              <a:t>Fuera de la lamina (habla de la practica): Cada una toma dos o tres minutos si se ejecuta con criterio, y juntas cubren los cuatro criterios de rubrica que mas peso tienen.</a:t>
+              <a:t>QUÉ ES (dilo así): En una base de datos no se audita cada pieza por separado sino la coherencia entre piezas: que todas describan el mismo sistema. Un ER bien dibujado y un DDL que ejecuta sin errores pueden describir dos bases distintas, y ninguna de las dos piezas «falla» por sí sola.</a:t>
+            </a:r>
+          </a:p>
+          <a:p/>
+          <a:p>
+            <a:r>
+              <a:t>CÓMO DARLA (≈5 min):</a:t>
+            </a:r>
+          </a:p>
+          <a:p>
+            <a:r>
+              <a:t>  • Al entrar: Las cinco piezas del proyecto, cada una con su visto: el ER, el DDL, la matriz de roles, los procedimientos y el informe de optimización. Revisadas solas, todas pasan.</a:t>
+            </a:r>
+          </a:p>
+          <a:p>
+            <a:r>
+              <a:t>  • Clic 1: El enlace entre el ER y el DDL se rompe: el diagrama se dibujó en la Clase 1 y el DDL se parchó en las Clases 3 a 8 (una tabla de auditoría, una columna nueva) sin volver al diagrama. Es el hallazgo más común y el más fácil de encontrar si se sabe dónde mirar.</a:t>
+            </a:r>
+          </a:p>
+          <a:p>
+            <a:r>
+              <a:t>  • Clic 2: Las cuatro verificaciones cruzadas, cada una entre dos piezas: el ER contra el DDL, la matriz de roles contra los GRANT, los procedimientos contra una llamada real y el informe contra el EXPLAIN de antes y después. Cada una toma dos o tres minutos.</a:t>
+            </a:r>
+          </a:p>
+          <a:p>
+            <a:r>
+              <a:t>  • Clic 3: La frase de la lámina: se audita la coherencia entre piezas, no cada pieza.</a:t>
+            </a:r>
+          </a:p>
+          <a:p/>
+          <a:p>
+            <a:r>
+              <a:t>EJEMPLO: La tabla audit_cita apareció en la Clase 4 con su trigger. Si el ER no la tiene, el DDL describe una base con una tabla más que el diagrama: hallazgo de coherencia, aunque las dos piezas estén bien hechas.</a:t>
+            </a:r>
+          </a:p>
+          <a:p/>
+          <a:p>
+            <a:r>
+              <a:t>SI PREGUNTAN:</a:t>
+            </a:r>
+          </a:p>
+          <a:p>
+            <a:r>
+              <a:t>  • «¿Y si el DDL es el correcto y el ER el viejo?» → Entonces se actualiza el ER: la fuente de verdad es lo que corre. El hallazgo es que no coinciden, no cuál de los dos tiene la culpa.</a:t>
+            </a:r>
+          </a:p>
+          <a:p/>
+          <a:p>
+            <a:r>
+              <a:t>CUIDADO: No aceptes como evidencia lo que el autor dice («sí, está actualizado»): pide abrir las dos piezas lado a lado.</a:t>
+            </a:r>
+          </a:p>
+          <a:p/>
+          <a:p>
+            <a:r>
+              <a:t>PASA A LA SIGUIENTE: Las dos primeras verificaciones, en detalle.</a:t>
             </a:r>
           </a:p>
         </p:txBody>
@@ -746,62 +1352,67 @@
           <a:lstStyle/>
           <a:p>
             <a:r>
-              <a:t>DESARROLLO (para explicarlo, no se proyecta):</a:t>
-            </a:r>
-          </a:p>
-          <a:p>
-            <a:r>
-              <a:t>Se recorre el diagrama entidad por entidad y se busca su CREATE TABLE: toda entidad sin tabla es un hallazgo.</a:t>
-            </a:r>
-          </a:p>
-          <a:p>
-            <a:r>
-              <a:t>Luego se recorre en sentido contrario, porque es el que nadie hace: toda tabla sin entidad en el diagrama tambien es un hallazgo, ya que significa que el modelo crecio sin registrarse.</a:t>
-            </a:r>
-          </a:p>
-          <a:p>
-            <a:r>
-              <a:t>Si el ER dice que una cita pertenece a exactamente una mascota, el DDL debe tener id_mascota con NOT NULL y una FOREIGN KEY hacia Mascota</a:t>
-            </a:r>
-          </a:p>
-          <a:p>
-            <a:r>
-              <a:t>Si dice que un dueno puede tener varias mascotas pero una mascota tiene un solo dueno, la clave foranea vive en Mascota y no en Dueno.</a:t>
-            </a:r>
-          </a:p>
-          <a:p>
-            <a:r>
-              <a:t>Una cardinalidad dibujada que no tiene su restriccion correspondiente en el DDL es decoracion, no modelo.</a:t>
-            </a:r>
-          </a:p>
-          <a:p>
-            <a:r>
-              <a:t>Se toma la matriz de la Clase 2 y se comprueba que los cuatro roles declarados existan en el script y que las celdas se hayan traducido en sentencias.</a:t>
-            </a:r>
-          </a:p>
-          <a:p>
-            <a:r>
-              <a:t>El hallazgo tipico aqui es el rol AUDITOR que en la matriz solo lee y en el script recibio privilegios de escritura, porque alguien copio el bloque de RECEPCION y cambio unicamente el nombre.</a:t>
-            </a:r>
-          </a:p>
-          <a:p>
-            <a:r>
-              <a:t>NOTAS:</a:t>
-            </a:r>
-          </a:p>
-          <a:p>
-            <a:r>
-              <a:t>Verificacion uno, ER contra DDL.</a:t>
-            </a:r>
-          </a:p>
-          <a:p>
-            <a:r>
-              <a:t>Despues se verifican las relaciones.</a:t>
-            </a:r>
-          </a:p>
-          <a:p>
-            <a:r>
-              <a:t>Verificacion dos, roles contra GRANT.</a:t>
+              <a:t>QUÉ ES (dilo así): La verificación uno compara el diagrama con el script en los dos sentidos y después mira las relaciones. La verificación dos compara la matriz de roles de la Clase 2 con los GRANT que de verdad se ejecutaron.</a:t>
+            </a:r>
+          </a:p>
+          <a:p/>
+          <a:p>
+            <a:r>
+              <a:t>CÓMO DARLA (≈6 min):</a:t>
+            </a:r>
+          </a:p>
+          <a:p>
+            <a:r>
+              <a:t>  • Al entrar: De ida: se recorre el ER entidad por entidad buscando su CREATE TABLE. Dueño, mascota y cita lo tienen; insumo no: entidad sin tabla.</a:t>
+            </a:r>
+          </a:p>
+          <a:p>
+            <a:r>
+              <a:t>  • Clic 1: De vuelta: el script tiene CREATE TABLE proveedor y el ER no tiene esa entidad. El modelo creció sin registrarse, y es el sentido que nadie revisa.</a:t>
+            </a:r>
+          </a:p>
+          <a:p>
+            <a:r>
+              <a:t>  • Clic 2: Las relaciones: si el ER dice que una cita pertenece a exactamente una mascota, el DDL debe tener id_mascota INT NOT NULL y REFERENCES mascota(id_mascota). Si dice que un dueño tiene varias mascotas, la clave foránea vive en mascota, no en dueño. Una cardinalidad sin restricción es decoración.</a:t>
+            </a:r>
+          </a:p>
+          <a:p>
+            <a:r>
+              <a:t>  • Clic 3: Verificación dos: la matriz dice que el auditor solo lee cita, pero el script le dio GRANT SELECT, INSERT, UPDATE ON cita TO auditor. Pasa cuando se copia el bloque de recepción y solo se cambia el nombre del rol.</a:t>
+            </a:r>
+          </a:p>
+          <a:p/>
+          <a:p>
+            <a:r>
+              <a:t>EJEMPLO: La consulta del catálogo que lista las claves foráneas devuelve 7 filas en la base completa del curso: una por cada relación del ER (cita con mascota y con veterinario, mascota con dueño, consulta con cita, factura con consulta y detalle_factura con factura y con insumo).</a:t>
+            </a:r>
+          </a:p>
+          <a:p/>
+          <a:p>
+            <a:r>
+              <a:t>SI PREGUNTAN:</a:t>
+            </a:r>
+          </a:p>
+          <a:p>
+            <a:r>
+              <a:t>  • «¿Cómo veo los privilegios reales de un rol?» → Con el catálogo: SELECT grantee, table_name, privilege_type FROM information_schema.role_table_grants WHERE grantee = 'auditor'; con el GRANT del ejemplo devuelve tres filas: INSERT, SELECT y UPDATE sobre cita.</a:t>
+            </a:r>
+          </a:p>
+          <a:p>
+            <a:r>
+              <a:t>  • «¿Una FK sin NOT NULL está mal?» → Depende de la cardinalidad: sin NOT NULL la relación es opcional. Si el ER dice «exactamente una», falta el NOT NULL.</a:t>
+            </a:r>
+          </a:p>
+          <a:p/>
+          <a:p>
+            <a:r>
+              <a:t>CUIDADO: Revisar solo de ida deja pasar las tablas que crecieron sin diagrama, que son justo las que la sustentación pregunta.</a:t>
+            </a:r>
+          </a:p>
+          <a:p/>
+          <a:p>
+            <a:r>
+              <a:t>PASA A LA SIGUIENTE: La verificación tres separa a quien va bien de quien no: que compile no es que sirva.</a:t>
             </a:r>
           </a:p>
         </p:txBody>
@@ -871,72 +1482,67 @@
           <a:lstStyle/>
           <a:p>
             <a:r>
-              <a:t>DESARROLLO (para explicarlo, no se proyecta):</a:t>
-            </a:r>
-          </a:p>
-          <a:p>
-            <a:r>
-              <a:t>La distincion que separa a un estudiante que va bien de uno que va mal es esta: un procedimiento que compila no es un procedimiento que funciona.</a:t>
-            </a:r>
-          </a:p>
-          <a:p>
-            <a:r>
-              <a:t>Primero CALL sp_agendar_cita con datos validos, que debe insertar la cita y devolver confirmacion.</a:t>
-            </a:r>
-          </a:p>
-          <a:p>
-            <a:r>
-              <a:t>Segundo, CALL sp_agendar_cita con el caso invalido que el propio estudiante declaro, es decir una mascota inactiva o un horario ya tomado, que debe devolver el mensaje de negocio y no un error crudo del motor.</a:t>
-            </a:r>
-          </a:p>
-          <a:p>
-            <a:r>
-              <a:t>Si el estudiante no puede mostrar la segunda ejecucion.</a:t>
-            </a:r>
-          </a:p>
-          <a:p>
-            <a:r>
-              <a:t>Un informe de optimizacion sin medicion no es optimizacion, es una opinion.</a:t>
-            </a:r>
-          </a:p>
-          <a:p>
-            <a:r>
-              <a:t>Si el estudiante creo tres indices y no puede senalar cual consulta aprovecha cada uno, el hallazgo es que indexo por costumbre y no por medicion, que es exactamente el error que se analiza como caso real en la Clase 13.</a:t>
-            </a:r>
-          </a:p>
-          <a:p>
-            <a:r>
-              <a:t>Ejemplo: un sp_agendar_cita que compila pero no valida la mascota inactiva pasa la primera ejecucion y falla la segunda, la que deberia haber sido rechazada.</a:t>
-            </a:r>
-          </a:p>
-          <a:p>
-            <a:r>
-              <a:t>NOTAS:</a:t>
-            </a:r>
-          </a:p>
-          <a:p>
-            <a:r>
-              <a:t>Verificacion tres, procedimientos invocables.</a:t>
-            </a:r>
-          </a:p>
-          <a:p>
-            <a:r>
-              <a:t>La prueba de humo dura un minuto y consiste en pedir dos ejecuciones y no una.</a:t>
-            </a:r>
-          </a:p>
-          <a:p>
-            <a:r>
-              <a:t>Verificacion cuatro, optimizacion.</a:t>
-            </a:r>
-          </a:p>
-          <a:p>
-            <a:r>
-              <a:t>Se exige la consulta original, el plan de ejecucion que la acompanaba, el cambio aplicado (indice creado o consulta reescrita) y el plan despues, mostrando que el motor paso de recorrido completo de tabla a acceso por indice.</a:t>
-            </a:r>
-          </a:p>
-          <a:p>
-            <a:r>
-              <a:t>Fuera de la lamina (habla de la practica): Si el estudiante no puede mostrar la segunda ejecucion, el procedimiento no tiene manejo de errores y eso resta puntos en los 25 de objetos programables.</a:t>
+              <a:t>QUÉ ES (dilo así): Las verificaciones tres y cuatro piden ejecuciones, no afirmaciones. Un procedimiento se prueba con dos llamadas: una que debe pasar y una que debe ser rechazada. Una optimización se prueba con el plan de ejecución de antes y de después.</a:t>
+            </a:r>
+          </a:p>
+          <a:p/>
+          <a:p>
+            <a:r>
+              <a:t>CÓMO DARLA (≈5 min):</a:t>
+            </a:r>
+          </a:p>
+          <a:p>
+            <a:r>
+              <a:t>  • Al entrar: CREATE PROCEDURE sp_agendar_cita(…) compiló. Eso solo dice que la sintaxis es correcta; todavía no se sabe si la regla funciona.</a:t>
+            </a:r>
+          </a:p>
+          <a:p>
+            <a:r>
+              <a:t>  • Clic 1: Caso válido: CALL sp_agendar_cita(1, 2, …) con una mascota activa (Firulais) y una franja libre: inserta la cita.</a:t>
+            </a:r>
+          </a:p>
+          <a:p>
+            <a:r>
+              <a:t>  • Clic 2: Caso inválido declarado: CALL sp_agendar_cita(3, 2, …) con Rocky, que está inactiva: el procedimiento aborta con «ERROR: la mascota 3 esta inactiva; no se agenda cita» y no inserta nada. Si el autor no puede mostrar esta segunda ejecución, el procedimiento no tiene manejo de errores.</a:t>
+            </a:r>
+          </a:p>
+          <a:p>
+            <a:r>
+              <a:t>  • Clic 3: Verificación cuatro: se pide la consulta, el plan de antes (Seq Scan on cita), el cambio aplicado y el plan de después (Index Scan using idx_cita_fecha_hora on cita). Sin medición, el informe es una opinión; y un índice que ninguna consulta aprovecha se anota como hallazgo.</a:t>
+            </a:r>
+          </a:p>
+          <a:p/>
+          <a:p>
+            <a:r>
+              <a:t>EJEMPLO: Un sp_agendar_cita que compila pero no valida la mascota inactiva pasa la primera llamada y también la segunda: inserta la cita de Rocky, que debía rechazarse. Solo la segunda ejecución lo delata.</a:t>
+            </a:r>
+          </a:p>
+          <a:p/>
+          <a:p>
+            <a:r>
+              <a:t>SI PREGUNTAN:</a:t>
+            </a:r>
+          </a:p>
+          <a:p>
+            <a:r>
+              <a:t>  • «¿Cómo confirmo que el caso inválido no dejó nada?» → Con SELECT COUNT(*) FROM cita; antes y después: el número no cambia.</a:t>
+            </a:r>
+          </a:p>
+          <a:p>
+            <a:r>
+              <a:t>  • «¿El plan de después siempre muestra Index Scan?» → No necesariamente: con pocas filas el planificador puede preferir Seq Scan aunque el índice exista. Lo que se exige es la medición y que el informe explique lo que muestra.</a:t>
+            </a:r>
+          </a:p>
+          <a:p/>
+          <a:p>
+            <a:r>
+              <a:t>CUIDADO: No marques en verde un procedimiento porque el autor dice que funciona: pide la ejecución del caso inválido en pantalla.</a:t>
+            </a:r>
+          </a:p>
+          <a:p/>
+          <a:p>
+            <a:r>
+              <a:t>PASA A LA SIGUIENTE: Las verificaciones en SQL: el catálogo responde qué existe de verdad.</a:t>
             </a:r>
           </a:p>
         </p:txBody>
@@ -1006,62 +1612,57 @@
           <a:lstStyle/>
           <a:p>
             <a:r>
-              <a:t>DESARROLLO (para explicarlo, no se proyecta):</a:t>
-            </a:r>
-          </a:p>
-          <a:p>
-            <a:r>
-              <a:t>Scope creep es el crecimiento no controlado del alcance: funcionalidad que se va agregando sin que nadie decida agregarla y sin que se quite nada a cambio.</a:t>
-            </a:r>
-          </a:p>
-          <a:p>
-            <a:r>
-              <a:t>En un proyecto de base de datos tiene un sintoma cuantificable, que es el numero de entidades. la clínica pide seis entidades minimas (Dueno, Mascota, Veterinario, Cita</a:t>
-            </a:r>
-          </a:p>
-          <a:p>
-            <a:r>
-              <a:t>Insumo y Factura con su detalle) y el rango sano al llegar a la Clase 11 es de seis a nueve, contando una o dos ampliaciones propias justificadas como Consulta o historial clinico.</a:t>
-            </a:r>
-          </a:p>
-          <a:p>
-            <a:r>
-              <a:t>Un estudiante que llega con quince entidades porque agrego proveedores, inventario multialmacen, portal para duenos y notificaciones no esta adelantado: esta repartiendo el mismo esfuerzo en el doble de superficie</a:t>
-            </a:r>
-          </a:p>
-          <a:p>
-            <a:r>
-              <a:t>Y termina con quince tablas vacias en vez de siete tablas con procedimientos probados.</a:t>
-            </a:r>
-          </a:p>
-          <a:p>
-            <a:r>
-              <a:t>La accion correctiva es explicita y se registra en el acta: las entidades que sobran se mueven a una seccion de alcance futuro del informe, con una frase que diga por que quedaron fuera.</a:t>
-            </a:r>
-          </a:p>
-          <a:p>
-            <a:r>
-              <a:t>NOTAS:</a:t>
-            </a:r>
-          </a:p>
-          <a:p>
-            <a:r>
-              <a:t>Existe tambien el problema inverso y menos visible.</a:t>
-            </a:r>
-          </a:p>
-          <a:p>
-            <a:r>
-              <a:t>Fuera de la lamina (habla de la practica): La rubrica no da puntos por cantidad de tablas: da 20 por modelo coherente y 25 por objetos programables con casos de prueba.</a:t>
-            </a:r>
-          </a:p>
-          <a:p>
-            <a:r>
-              <a:t>Fuera de la lamina (habla de la practica): Eso no resta puntos, al contrario, declarar el limite es una senal de madurez que se valora en la sustentacion.</a:t>
-            </a:r>
-          </a:p>
-          <a:p>
-            <a:r>
-              <a:t>Fuera de la lamina (habla de la practica): Existe tambien el problema inverso y menos visible: el estudiante que recorto tanto que ya no tiene material para los 25 puntos de procedimientos, funciones y disparadores, y ese caso tambien es un hallazgo que hay que escribir.</a:t>
+              <a:t>QUÉ ES (dilo así): Scope creep es el crecimiento no controlado del alcance: se agregan cosas sin decidirlo y sin quitar nada. En un proyecto de base de datos tiene un síntoma que se cuenta: el número de entidades.</a:t>
+            </a:r>
+          </a:p>
+          <a:p/>
+          <a:p>
+            <a:r>
+              <a:t>CÓMO DARLA (≈4 min):</a:t>
+            </a:r>
+          </a:p>
+          <a:p>
+            <a:r>
+              <a:t>  • Al entrar: El mínimo son seis entidades (dueño, mascota, veterinario, cita, insumo y factura con su detalle) y el rango sano llega a nueve con una o dos ampliaciones justificadas, como consulta o un historial clínico. El modelo del curso tiene 8 tablas: dentro del rango.</a:t>
+            </a:r>
+          </a:p>
+          <a:p>
+            <a:r>
+              <a:t>  • Clic 1: Se agregan proveedores, inventario multialmacén, portal de dueños, notificaciones… y se llega a 15. Nadie decidió agregarlas y nada se quitó a cambio.</a:t>
+            </a:r>
+          </a:p>
+          <a:p>
+            <a:r>
+              <a:t>  • Clic 2: Mismo esfuerzo, el doble de superficie: se termina con quince tablas vacías en vez de ocho con procedimientos probados. La acción va al acta: las sobrantes pasan a una sección de alcance futuro, con su porqué.</a:t>
+            </a:r>
+          </a:p>
+          <a:p/>
+          <a:p>
+            <a:r>
+              <a:t>EJEMPLO: Un hallazgo bien escrito: «Artefacto: ER. Observación: 15 entidades, 7 sin procedimientos ni datos. Acción: mover proveedor, almacén, portal y notificación a alcance futuro.»</a:t>
+            </a:r>
+          </a:p>
+          <a:p/>
+          <a:p>
+            <a:r>
+              <a:t>SI PREGUNTAN:</a:t>
+            </a:r>
+          </a:p>
+          <a:p>
+            <a:r>
+              <a:t>  • «¿Mover entidades a alcance futuro no se ve mal?» → Al contrario: declarar el límite con su razón es señal de madurez y se valora al sustentar.</a:t>
+            </a:r>
+          </a:p>
+          <a:p/>
+          <a:p>
+            <a:r>
+              <a:t>CUIDADO: Existe el problema inverso: quien recortó tanto que ya no tiene material para procedimientos, funciones y triggers. También se escribe como hallazgo.</a:t>
+            </a:r>
+          </a:p>
+          <a:p/>
+          <a:p>
+            <a:r>
+              <a:t>PASA A LA SIGUIENTE: ¿Cómo se escribe un hallazgo para que sirva? Tiene una anatomía fija.</a:t>
             </a:r>
           </a:p>
         </p:txBody>
@@ -1131,77 +1732,57 @@
           <a:lstStyle/>
           <a:p>
             <a:r>
-              <a:t>DESARROLLO (para explicarlo, no se proyecta):</a:t>
-            </a:r>
-          </a:p>
-          <a:p>
-            <a:r>
-              <a:t>La retroalimentacion util tiene una anatomia fija, y conviene que el docente la escriba siempre igual porque asi el acta se vuelve una lista de tareas y no un desahogo.</a:t>
-            </a:r>
-          </a:p>
-          <a:p>
-            <a:r>
-              <a:t>Un hallazgo bien formulado tiene cinco partes: artefacto, observacion verificable, impacto, accion y responsable con fecha.</a:t>
-            </a:r>
-          </a:p>
-          <a:p>
-            <a:r>
-              <a:t>Retroalimentacion inutil: «el modelo esta flojo, mejorenlo»; no dice que mirar ni como saber cuando esta resuelto.</a:t>
-            </a:r>
-          </a:p>
-          <a:p>
-            <a:r>
-              <a:t>Retroalimentacion accionable: «Artefacto: script DDL.</a:t>
-            </a:r>
-          </a:p>
-          <a:p>
-            <a:r>
-              <a:t>Observacion: la tabla detalle_factura no tiene FOREIGN KEY hacia insumo, aunque el ER dibuja la relacion.</a:t>
-            </a:r>
-          </a:p>
-          <a:p>
-            <a:r>
-              <a:t>Impacto: se pueden insertar detalles con insumos que no existen.</a:t>
-            </a:r>
-          </a:p>
-          <a:p>
-            <a:r>
-              <a:t>Accion: agregar la restriccion y volver a ejecutar el script completo desde cero en un entorno limpio.</a:t>
-            </a:r>
-          </a:p>
-          <a:p>
-            <a:r>
-              <a:t>Fecha: antes de la Clase 12.» La diferencia entre las dos no es cortesia, es verificabilidad: el segundo hallazgo se puede cerrar y cualquiera puede comprobar que se cerro.</a:t>
-            </a:r>
-          </a:p>
-          <a:p>
-            <a:r>
-              <a:t>La regla de dosificacion es de tres a cinco hallazgos por estudiante.</a:t>
-            </a:r>
-          </a:p>
-          <a:p>
-            <a:r>
-              <a:t>NOTAS:</a:t>
-            </a:r>
-          </a:p>
-          <a:p>
-            <a:r>
-              <a:t>Comparense los dos extremos.</a:t>
-            </a:r>
-          </a:p>
-          <a:p>
-            <a:r>
-              <a:t>Responsable: Carlos.</a:t>
-            </a:r>
-          </a:p>
-          <a:p>
-            <a:r>
-              <a:t>Fuera de la lamina (habla de la practica): Impacto: se pueden insertar detalles con insumos que no existen; afecta los 20 puntos de modelo coherente.</a:t>
-            </a:r>
-          </a:p>
-          <a:p>
-            <a:r>
-              <a:t>Fuera de la lamina (habla de la practica): La regla de dosificacion es de tres a cinco hallazgos por estudiante, priorizados por puntos de rubrica en riesgo; mas de cinco desmoraliza y nadie los cierra, y menos de tres casi siempre significa que la revision fue superficial.</a:t>
+              <a:t>QUÉ ES (dilo así): La retroalimentación útil se escribe siempre con la misma forma, para que el acta sea una lista de tareas y no un desahogo. Cada hallazgo dice qué pieza, qué se observó, por qué importa, qué hacer y quién lo hace para cuándo.</a:t>
+            </a:r>
+          </a:p>
+          <a:p/>
+          <a:p>
+            <a:r>
+              <a:t>CÓMO DARLA (≈5 min):</a:t>
+            </a:r>
+          </a:p>
+          <a:p>
+            <a:r>
+              <a:t>  • Al entrar: La versión inútil: «el modelo está flojo, mejórenlo». No dice qué mirar ni cómo saber cuándo está resuelto.</a:t>
+            </a:r>
+          </a:p>
+          <a:p>
+            <a:r>
+              <a:t>  • Clic 1: La versión accionable, parte por parte: artefacto, el script DDL; observación, detalle_factura no tiene FOREIGN KEY hacia insumo aunque el ER dibuja la relación; impacto, se pueden insertar detalles con insumos que no existen; acción, agregar la restricción y re-ejecutar el script completo desde cero; responsable y fecha, el autor, antes de la próxima sesión.</a:t>
+            </a:r>
+          </a:p>
+          <a:p>
+            <a:r>
+              <a:t>  • Clic 2: La diferencia no es cortesía, es verificabilidad. Y la dosis: de tres a cinco hallazgos por persona; más de cinco desmoraliza y nadie los cierra, menos de tres suele ser una revisión superficial.</a:t>
+            </a:r>
+          </a:p>
+          <a:p/>
+          <a:p>
+            <a:r>
+              <a:t>EJEMPLO: La observación se prueba con SQL: INSERT INTO detalle_factura (id_factura, id_insumo, cantidad, precio_unit) VALUES (1, 999, 1, 1000); si entra, falta la FK; si responde «violates foreign key constraint», el hallazgo está cerrado.</a:t>
+            </a:r>
+          </a:p>
+          <a:p/>
+          <a:p>
+            <a:r>
+              <a:t>SI PREGUNTAN:</a:t>
+            </a:r>
+          </a:p>
+          <a:p>
+            <a:r>
+              <a:t>  • «¿Por qué re-ejecutar todo el script desde cero?» → Porque un ALTER aplicado a mano en la base de uno no queda en el script: la prueba de que quedó es que el script completo corra limpio en una base vacía.</a:t>
+            </a:r>
+          </a:p>
+          <a:p/>
+          <a:p>
+            <a:r>
+              <a:t>CUIDADO: La observación tiene que ser verificable: «la FK no existe» se comprueba; «el modelo está raro», no.</a:t>
+            </a:r>
+          </a:p>
+          <a:p/>
+          <a:p>
+            <a:r>
+              <a:t>PASA A LA SIGUIENTE: ¿Y si la revisión no encuentra nada? Entonces se desperdició.</a:t>
             </a:r>
           </a:p>
         </p:txBody>
@@ -1271,67 +1852,236 @@
           <a:lstStyle/>
           <a:p>
             <a:r>
-              <a:t>DESARROLLO (para explicarlo, no se proyecta):</a:t>
-            </a:r>
-          </a:p>
-          <a:p>
-            <a:r>
-              <a:t>Un checkpoint sin hallazgos concretos es un checkpoint desperdiciado, y esa afirmacion merece justificacion porque suena severa.</a:t>
-            </a:r>
-          </a:p>
-          <a:p>
-            <a:r>
-              <a:t>El unico valor de un punto de control intermedio es que todavia existe tiempo para corregir, y ese valor se realiza solo si de la sesion sale una lista escrita de cosas por corregir.</a:t>
-            </a:r>
-          </a:p>
-          <a:p>
-            <a:r>
-              <a:t>Cuando el docente dice «todo bien, sigan asi», el estudiante interpreta legitimamente que su trabajo esta aprobado, deja de revisarlo, y el defecto reaparece en la entrega final cuando ya no hay clases para arreglarlo: es un costo diferido, no un ahorro.</a:t>
-            </a:r>
-          </a:p>
-          <a:p>
-            <a:r>
-              <a:t>La primera: «esto tiene nota?».</a:t>
-            </a:r>
-          </a:p>
-          <a:p>
-            <a:r>
-              <a:t>La segunda: «si quien me audita encuentra fallas, me baja la nota?».</a:t>
-            </a:r>
-          </a:p>
-          <a:p>
-            <a:r>
-              <a:t>Y revisar el trabajo de otro tiene un beneficio propio bien documentado: los defectos ajenos se ven mucho mas rapido que los propios, y casi siempre quien audita vuelve a su carpeta y arregla en silencio el mismo problema que acaba de senalar.</a:t>
-            </a:r>
-          </a:p>
-          <a:p>
-            <a:r>
-              <a:t>Todo esto se apoya en lo hecho hasta la Clase 10 (el informe de escenarios de concurrencia es una de las evidencias que hoy se audita) y alimenta directamente la Clase 12</a:t>
-            </a:r>
-          </a:p>
-          <a:p>
-            <a:r>
-              <a:t>Donde el contrato de operaciones solo puede escribirse sobre procedimientos que existan y funcionen, y la Clase 15, donde se sustenta.</a:t>
-            </a:r>
-          </a:p>
-          <a:p>
-            <a:r>
-              <a:t>NOTAS:</a:t>
-            </a:r>
-          </a:p>
-          <a:p>
-            <a:r>
-              <a:t>Aqui aparecen las dos preguntas previsibles del estudiante.</a:t>
-            </a:r>
-          </a:p>
-          <a:p>
-            <a:r>
-              <a:t>Fuera de la lamina (habla de la practica): La respuesta es que el checkpoint en si no califica el producto, pero es la ultima oportunidad de mover puntos de la rubrica antes de la entrega, y por eso conviene llegar con lo peor y no con lo mejor: un estudiante que esconde su parte floja para no verse mal pierde justamente la revision que la habria arreglado.</a:t>
-            </a:r>
-          </a:p>
-          <a:p>
-            <a:r>
-              <a:t>Fuera de la lamina (habla de la practica): No, porque el auditor par no califica.</a:t>
+              <a:t>QUÉ ES (dilo así): Un punto de control intermedio solo vale si de él sale una lista de cosas por corregir mientras aún hay clases para hacerlo. Un «todo bien» no ahorra trabajo: lo aplaza al momento en que ya no se puede arreglar.</a:t>
+            </a:r>
+          </a:p>
+          <a:p/>
+          <a:p>
+            <a:r>
+              <a:t>CÓMO DARLA (≈4 min):</a:t>
+            </a:r>
+          </a:p>
+          <a:p>
+            <a:r>
+              <a:t>  • Al entrar: La línea del tiempo: checkpoint y entrega. Entre los dos, la franja verde es el tiempo que queda para corregir.</a:t>
+            </a:r>
+          </a:p>
+          <a:p>
+            <a:r>
+              <a:t>  • Clic 1: Con hallazgos concretos: el defecto aparece en el checkpoint, se anota y se corrige dentro de esa franja.</a:t>
+            </a:r>
+          </a:p>
+          <a:p>
+            <a:r>
+              <a:t>  • Clic 2: Con «todo bien, sigan así»: el estudiante entiende, con razón, que su trabajo está aprobado; deja de revisarlo y el defecto llega intacto a la entrega, cuando ya no hay tiempo. Es un costo diferido, no un ahorro.</a:t>
+            </a:r>
+          </a:p>
+          <a:p/>
+          <a:p>
+            <a:r>
+              <a:t>EJEMPLO: La revisión entre pares tiene un beneficio propio: quien revisa casi siempre vuelve a su carpeta y arregla en silencio el mismo problema que acaba de señalar.</a:t>
+            </a:r>
+          </a:p>
+          <a:p/>
+          <a:p>
+            <a:r>
+              <a:t>SI PREGUNTAN:</a:t>
+            </a:r>
+          </a:p>
+          <a:p>
+            <a:r>
+              <a:t>  • «¿Llego con lo mejor o con lo peor?» → Con lo peor: es lo que la revisión puede arreglar. Esconder la parte floja es perder justo la ayuda que se vino a buscar.</a:t>
+            </a:r>
+          </a:p>
+          <a:p/>
+          <a:p>
+            <a:r>
+              <a:t>CUIDADO: Convertir el checkpoint en una clase de repaso porque incomoda no tener tema nuevo: el tiempo se va explicando y nadie sale con su acta, que era el producto del día.</a:t>
+            </a:r>
+          </a:p>
+          <a:p/>
+          <a:p>
+            <a:r>
+              <a:t>PASA A LA SIGUIENTE: Para que los hallazgos salgan de datos y no de opiniones: más consultas al catálogo.</a:t>
+            </a:r>
+          </a:p>
+        </p:txBody>
+      </p:sp>
+      <p:sp>
+        <p:nvSpPr>
+          <p:cNvPr id="4" name="Slide Number Placeholder 3"/>
+          <p:cNvSpPr>
+            <a:spLocks noGrp="1"/>
+          </p:cNvSpPr>
+          <p:nvPr>
+            <p:ph type="sldNum" idx="5" sz="quarter"/>
+          </p:nvPr>
+        </p:nvSpPr>
+        <p:spPr/>
+      </p:sp>
+    </p:spTree>
+  </p:cSld>
+  <p:clrMapOvr>
+    <a:masterClrMapping/>
+  </p:clrMapOvr>
+</p:notes>
+</file>
+
+<file path=ppt/notesSlides/notesSlide8.xml><?xml version="1.0" encoding="utf-8"?>
+<p:notes xmlns:a="http://schemas.openxmlformats.org/drawingml/2006/main" xmlns:p="http://schemas.openxmlformats.org/presentationml/2006/main" xmlns:r="http://schemas.openxmlformats.org/officeDocument/2006/relationships">
+  <p:cSld>
+    <p:spTree>
+      <p:nvGrpSpPr>
+        <p:cNvPr id="1" name=""/>
+        <p:cNvGrpSpPr/>
+        <p:nvPr/>
+      </p:nvGrpSpPr>
+      <p:grpSpPr>
+        <a:xfrm>
+          <a:off x="0" y="0"/>
+          <a:ext cx="0" cy="0"/>
+          <a:chOff x="0" y="0"/>
+          <a:chExt cx="0" cy="0"/>
+        </a:xfrm>
+      </p:grpSpPr>
+      <p:sp>
+        <p:nvSpPr>
+          <p:cNvPr id="2" name="Slide Image Placeholder 1"/>
+          <p:cNvSpPr>
+            <a:spLocks noGrp="1"/>
+          </p:cNvSpPr>
+          <p:nvPr>
+            <p:ph type="sldImg" idx="2"/>
+          </p:nvPr>
+        </p:nvSpPr>
+        <p:spPr/>
+      </p:sp>
+      <p:sp>
+        <p:nvSpPr>
+          <p:cNvPr id="3" name="Notes Placeholder 2"/>
+          <p:cNvSpPr>
+            <a:spLocks noGrp="1"/>
+          </p:cNvSpPr>
+          <p:nvPr>
+            <p:ph type="body" idx="3" sz="quarter"/>
+          </p:nvPr>
+        </p:nvSpPr>
+        <p:spPr/>
+        <p:txBody>
+          <a:bodyPr/>
+          <a:lstStyle/>
+          <a:p>
+            <a:r>
+              <a:t>QUÉ ES (dilo así): Hoy no hay SQL nuevo: hoy se revisa lo construido. Una revisión técnica bien hecha encuentra los defectos mientras todavía hay tiempo de corregirlos, y deja una lista escrita de qué arreglar.</a:t>
+            </a:r>
+          </a:p>
+          <a:p/>
+          <a:p>
+            <a:r>
+              <a:t>CÓMO DARLA (≈4 min):</a:t>
+            </a:r>
+          </a:p>
+          <a:p>
+            <a:r>
+              <a:t>  • Al entrar: Lee el tema y pregunta: «si hoy alguien abriera su base sin conocerlos, ¿qué sería lo primero que no coincide con lo que dice su diagrama?». Toma dos respuestas.</a:t>
+            </a:r>
+          </a:p>
+          <a:p>
+            <a:r>
+              <a:t>  • Después: Cierra: «al final cada uno sale con su acta de hallazgos; cada hallazgo, demostrado con una ejecución».</a:t>
+            </a:r>
+          </a:p>
+          <a:p/>
+          <a:p>
+            <a:r>
+              <a:t>CUIDADO: Esta sesión es doble: la Clase 11 y la 12 van el mismo día. Cuida el tiempo de la revisión para que la integración no quede comprimida.</a:t>
+            </a:r>
+          </a:p>
+          <a:p/>
+          <a:p>
+            <a:r>
+              <a:t>PASA A LA SIGUIENTE: Primero, qué es una revisión técnica y con qué producto se sale.</a:t>
+            </a:r>
+          </a:p>
+        </p:txBody>
+      </p:sp>
+      <p:sp>
+        <p:nvSpPr>
+          <p:cNvPr id="4" name="Slide Number Placeholder 3"/>
+          <p:cNvSpPr>
+            <a:spLocks noGrp="1"/>
+          </p:cNvSpPr>
+          <p:nvPr>
+            <p:ph type="sldNum" idx="5" sz="quarter"/>
+          </p:nvPr>
+        </p:nvSpPr>
+        <p:spPr/>
+      </p:sp>
+    </p:spTree>
+  </p:cSld>
+  <p:clrMapOvr>
+    <a:masterClrMapping/>
+  </p:clrMapOvr>
+</p:notes>
+</file>
+
+<file path=ppt/notesSlides/notesSlide9.xml><?xml version="1.0" encoding="utf-8"?>
+<p:notes xmlns:a="http://schemas.openxmlformats.org/drawingml/2006/main" xmlns:p="http://schemas.openxmlformats.org/presentationml/2006/main" xmlns:r="http://schemas.openxmlformats.org/officeDocument/2006/relationships">
+  <p:cSld>
+    <p:spTree>
+      <p:nvGrpSpPr>
+        <p:cNvPr id="1" name=""/>
+        <p:cNvGrpSpPr/>
+        <p:nvPr/>
+      </p:nvGrpSpPr>
+      <p:grpSpPr>
+        <a:xfrm>
+          <a:off x="0" y="0"/>
+          <a:ext cx="0" cy="0"/>
+          <a:chOff x="0" y="0"/>
+          <a:chExt cx="0" cy="0"/>
+        </a:xfrm>
+      </p:grpSpPr>
+      <p:sp>
+        <p:nvSpPr>
+          <p:cNvPr id="2" name="Slide Image Placeholder 1"/>
+          <p:cNvSpPr>
+            <a:spLocks noGrp="1"/>
+          </p:cNvSpPr>
+          <p:nvPr>
+            <p:ph type="sldImg" idx="2"/>
+          </p:nvPr>
+        </p:nvSpPr>
+        <p:spPr/>
+      </p:sp>
+      <p:sp>
+        <p:nvSpPr>
+          <p:cNvPr id="3" name="Notes Placeholder 2"/>
+          <p:cNvSpPr>
+            <a:spLocks noGrp="1"/>
+          </p:cNvSpPr>
+          <p:nvPr>
+            <p:ph type="body" idx="3" sz="quarter"/>
+          </p:nvPr>
+        </p:nvSpPr>
+        <p:spPr/>
+        <p:txBody>
+          <a:bodyPr/>
+          <a:lstStyle/>
+          <a:p>
+            <a:r>
+              <a:t>QUÉ ES (dilo así): El recorrido del bloque: teoría con una lámina por concepto, demo de una revisión real y práctica opcional.</a:t>
+            </a:r>
+          </a:p>
+          <a:p/>
+          <a:p>
+            <a:r>
+              <a:t>CÓMO DARLA (≈1 min):</a:t>
+            </a:r>
+          </a:p>
+          <a:p>
+            <a:r>
+              <a:t>  • Al entrar: Señala solo los tramos; no te detengas. La práctica está en la carpeta de la clase y es opcional.</a:t>
             </a:r>
           </a:p>
         </p:txBody>
@@ -5046,7 +5796,25 @@
                 </a:solidFill>
                 <a:latin typeface="Calibri"/>
               </a:rPr>
-              <a:t>–   La retroalimentacion util tiene una anatomia fija, y conviene que el docente la escriba siempre igual porque asi el acta se vuelve una lista de…</a:t>
+              <a:t>–   «El modelo está flojo, mejórenlo» no sirve, porque no dice </a:t>
+            </a:r>
+            <a:r>
+              <a:rPr sz="2000" b="1" i="0">
+                <a:solidFill>
+                  <a:srgbClr val="333333"/>
+                </a:solidFill>
+                <a:latin typeface="Calibri"/>
+              </a:rPr>
+              <a:t>qué mirar</a:t>
+            </a:r>
+            <a:r>
+              <a:rPr sz="2000" b="0" i="0">
+                <a:solidFill>
+                  <a:srgbClr val="333333"/>
+                </a:solidFill>
+                <a:latin typeface="Calibri"/>
+              </a:rPr>
+              <a:t> ni cuándo queda resuelto.</a:t>
             </a:r>
           </a:p>
           <a:p>
@@ -5062,7 +5830,25 @@
                 </a:solidFill>
                 <a:latin typeface="Calibri"/>
               </a:rPr>
-              <a:t>–   Un hallazgo bien formulado tiene cinco partes: artefacto, observacion verificable, impacto, accion y responsable con fecha.</a:t>
+              <a:t>–   Un hallazgo útil tiene cinco partes: </a:t>
+            </a:r>
+            <a:r>
+              <a:rPr sz="2000" b="1" i="0">
+                <a:solidFill>
+                  <a:srgbClr val="333333"/>
+                </a:solidFill>
+                <a:latin typeface="Calibri"/>
+              </a:rPr>
+              <a:t>artefacto, observación, impacto, acción y responsable con fecha</a:t>
+            </a:r>
+            <a:r>
+              <a:rPr sz="2000" b="0" i="0">
+                <a:solidFill>
+                  <a:srgbClr val="333333"/>
+                </a:solidFill>
+                <a:latin typeface="Calibri"/>
+              </a:rPr>
+              <a:t>.</a:t>
             </a:r>
           </a:p>
           <a:p>
@@ -5078,7 +5864,59 @@
                 </a:solidFill>
                 <a:latin typeface="Calibri"/>
               </a:rPr>
-              <a:t>–   Retroalimentacion inutil: «el modelo esta flojo, mejorenlo»; no dice que mirar ni como saber cuando esta resuelto.</a:t>
+              <a:t>–   La diferencia es la </a:t>
+            </a:r>
+            <a:r>
+              <a:rPr sz="2000" b="1" i="0">
+                <a:solidFill>
+                  <a:srgbClr val="333333"/>
+                </a:solidFill>
+                <a:latin typeface="Calibri"/>
+              </a:rPr>
+              <a:t>verificabilidad</a:t>
+            </a:r>
+            <a:r>
+              <a:rPr sz="2000" b="0" i="0">
+                <a:solidFill>
+                  <a:srgbClr val="333333"/>
+                </a:solidFill>
+                <a:latin typeface="Calibri"/>
+              </a:rPr>
+              <a:t>: cualquiera puede comprobar que el hallazgo se cerró.</a:t>
+            </a:r>
+          </a:p>
+          <a:p>
+            <a:pPr>
+              <a:spcAft>
+                <a:spcPts val="800"/>
+              </a:spcAft>
+            </a:pPr>
+            <a:r>
+              <a:rPr sz="2000" b="0" i="0">
+                <a:solidFill>
+                  <a:srgbClr val="333333"/>
+                </a:solidFill>
+                <a:latin typeface="Calibri"/>
+              </a:rPr>
+              <a:t>–   Se escriben de </a:t>
+            </a:r>
+            <a:r>
+              <a:rPr sz="2000" b="1" i="0">
+                <a:solidFill>
+                  <a:srgbClr val="333333"/>
+                </a:solidFill>
+                <a:latin typeface="Calibri"/>
+              </a:rPr>
+              <a:t>3 a 5</a:t>
+            </a:r>
+            <a:r>
+              <a:rPr sz="2000" b="0" i="0">
+                <a:solidFill>
+                  <a:srgbClr val="333333"/>
+                </a:solidFill>
+                <a:latin typeface="Calibri"/>
+              </a:rPr>
+              <a:t> hallazgos por persona, los de más peso primero.</a:t>
             </a:r>
           </a:p>
         </p:txBody>
@@ -5586,7 +6424,25 @@
                 </a:solidFill>
                 <a:latin typeface="Calibri"/>
               </a:rPr>
-              <a:t>–   Un checkpoint sin hallazgos concretos es un checkpoint desperdiciado, y esa afirmacion merece justificacion porque suena severa.</a:t>
+              <a:t>–   El único valor de un </a:t>
+            </a:r>
+            <a:r>
+              <a:rPr sz="2000" b="1" i="0">
+                <a:solidFill>
+                  <a:srgbClr val="333333"/>
+                </a:solidFill>
+                <a:latin typeface="Calibri"/>
+              </a:rPr>
+              <a:t>checkpoint</a:t>
+            </a:r>
+            <a:r>
+              <a:rPr sz="2000" b="0" i="0">
+                <a:solidFill>
+                  <a:srgbClr val="333333"/>
+                </a:solidFill>
+                <a:latin typeface="Calibri"/>
+              </a:rPr>
+              <a:t> es que todavía hay tiempo para corregir.</a:t>
             </a:r>
           </a:p>
           <a:p>
@@ -5602,7 +6458,25 @@
                 </a:solidFill>
                 <a:latin typeface="Calibri"/>
               </a:rPr>
-              <a:t>–   El unico valor de un punto de control intermedio es que todavia existe tiempo para corregir.</a:t>
+              <a:t>–   Con hallazgos escritos, el defecto se </a:t>
+            </a:r>
+            <a:r>
+              <a:rPr sz="2000" b="1" i="0">
+                <a:solidFill>
+                  <a:srgbClr val="333333"/>
+                </a:solidFill>
+                <a:latin typeface="Calibri"/>
+              </a:rPr>
+              <a:t>corrige a tiempo</a:t>
+            </a:r>
+            <a:r>
+              <a:rPr sz="2000" b="0" i="0">
+                <a:solidFill>
+                  <a:srgbClr val="333333"/>
+                </a:solidFill>
+                <a:latin typeface="Calibri"/>
+              </a:rPr>
+              <a:t>, antes de la entrega.</a:t>
             </a:r>
           </a:p>
           <a:p>
@@ -5618,7 +6492,25 @@
                 </a:solidFill>
                 <a:latin typeface="Calibri"/>
               </a:rPr>
-              <a:t>–   Cuando el docente dice «todo bien, sigan asi», el estudiante interpreta legitimamente que su trabajo esta aprobado, deja de revisarlo.</a:t>
+              <a:t>–   «Todo bien, sigan así» hace que se deje de revisar y el defecto </a:t>
+            </a:r>
+            <a:r>
+              <a:rPr sz="2000" b="1" i="0">
+                <a:solidFill>
+                  <a:srgbClr val="333333"/>
+                </a:solidFill>
+                <a:latin typeface="Calibri"/>
+              </a:rPr>
+              <a:t>llega a la entrega</a:t>
+            </a:r>
+            <a:r>
+              <a:rPr sz="2000" b="0" i="0">
+                <a:solidFill>
+                  <a:srgbClr val="333333"/>
+                </a:solidFill>
+                <a:latin typeface="Calibri"/>
+              </a:rPr>
+              <a:t>.</a:t>
             </a:r>
           </a:p>
           <a:p>
@@ -5634,7 +6526,25 @@
                 </a:solidFill>
                 <a:latin typeface="Calibri"/>
               </a:rPr>
-              <a:t>–   La primera: «esto tiene nota?».</a:t>
+              <a:t>–   Revisar el trabajo de otro ayuda: los </a:t>
+            </a:r>
+            <a:r>
+              <a:rPr sz="2000" b="1" i="0">
+                <a:solidFill>
+                  <a:srgbClr val="333333"/>
+                </a:solidFill>
+                <a:latin typeface="Calibri"/>
+              </a:rPr>
+              <a:t>defectos ajenos</a:t>
+            </a:r>
+            <a:r>
+              <a:rPr sz="2000" b="0" i="0">
+                <a:solidFill>
+                  <a:srgbClr val="333333"/>
+                </a:solidFill>
+                <a:latin typeface="Calibri"/>
+              </a:rPr>
+              <a:t> se ven más rápido que los propios.</a:t>
             </a:r>
           </a:p>
         </p:txBody>
@@ -7756,14 +8666,83 @@
       </p:sp>
       <p:sp>
         <p:nvSpPr>
-          <p:cNvPr id="5" name="TextBox 4"/>
+          <p:cNvPr id="5" name="Rounded Rectangle 4"/>
+          <p:cNvSpPr/>
+          <p:nvPr/>
+        </p:nvSpPr>
+        <p:spPr>
+          <a:xfrm>
+            <a:off x="5797149" y="1343926"/>
+            <a:ext cx="6010497" cy="4837658"/>
+          </a:xfrm>
+          <a:prstGeom prst="roundRect">
+            <a:avLst>
+              <a:gd name="adj" fmla="val 4000"/>
+            </a:avLst>
+          </a:prstGeom>
+          <a:solidFill>
+            <a:srgbClr val="E8EEF4"/>
+          </a:solidFill>
+          <a:ln>
+            <a:noFill/>
+          </a:ln>
+        </p:spPr>
+        <p:style>
+          <a:lnRef idx="1">
+            <a:schemeClr val="accent1"/>
+          </a:lnRef>
+          <a:fillRef idx="3">
+            <a:schemeClr val="accent1"/>
+          </a:fillRef>
+          <a:effectRef idx="2">
+            <a:schemeClr val="accent1"/>
+          </a:effectRef>
+          <a:fontRef idx="minor">
+            <a:schemeClr val="lt1"/>
+          </a:fontRef>
+        </p:style>
+        <p:txBody>
+          <a:bodyPr rtlCol="0" anchor="ctr"/>
+          <a:lstStyle/>
+          <a:p>
+            <a:pPr algn="ctr"/>
+          </a:p>
+        </p:txBody>
+      </p:sp>
+      <p:pic>
+        <p:nvPicPr>
+          <p:cNvPr id="6" name="Picture 5" descr="ilus-demo-paso1.png"/>
+          <p:cNvPicPr>
+            <a:picLocks noChangeAspect="1"/>
+          </p:cNvPicPr>
+          <p:nvPr/>
+        </p:nvPicPr>
+        <p:blipFill>
+          <a:blip r:embed="rId2"/>
+          <a:stretch>
+            <a:fillRect/>
+          </a:stretch>
+        </p:blipFill>
+        <p:spPr>
+          <a:xfrm>
+            <a:off x="5870301" y="1417078"/>
+            <a:ext cx="5864193" cy="4691354"/>
+          </a:xfrm>
+          <a:prstGeom prst="rect">
+            <a:avLst/>
+          </a:prstGeom>
+        </p:spPr>
+      </p:pic>
+      <p:sp>
+        <p:nvSpPr>
+          <p:cNvPr id="7" name="TextBox 6"/>
           <p:cNvSpPr txBox="1"/>
           <p:nvPr/>
         </p:nvSpPr>
         <p:spPr>
           <a:xfrm>
-            <a:off x="457200" y="1170432"/>
-            <a:ext cx="11277295" cy="5230368"/>
+            <a:off x="457200" y="1353312"/>
+            <a:ext cx="5093061" cy="5047488"/>
           </a:xfrm>
           <a:prstGeom prst="rect">
             <a:avLst/>
@@ -7788,7 +8767,7 @@
                 </a:solidFill>
                 <a:latin typeface="Calibri"/>
               </a:rPr>
-              <a:t>–   </a:t>
+              <a:t>–   Cada hallazgo sale de una </a:t>
             </a:r>
             <a:r>
               <a:rPr sz="2000" b="1" i="0">
@@ -7797,7 +8776,7 @@
                 </a:solidFill>
                 <a:latin typeface="Calibri"/>
               </a:rPr>
-              <a:t>Herramienta:</a:t>
+              <a:t>ejecución</a:t>
             </a:r>
             <a:r>
               <a:rPr sz="2000" b="0" i="0">
@@ -7806,7 +8785,7 @@
                 </a:solidFill>
                 <a:latin typeface="Calibri"/>
               </a:rPr>
-              <a:t> Live SQL / DB Fiddle + draw.io</a:t>
+              <a:t>: el catálogo, el CALL válido y el CALL inválido.</a:t>
             </a:r>
           </a:p>
           <a:p>
@@ -7822,7 +8801,7 @@
                 </a:solidFill>
                 <a:latin typeface="Calibri"/>
               </a:rPr>
-              <a:t>–   </a:t>
+              <a:t>–   El ER se compara con el </a:t>
             </a:r>
             <a:r>
               <a:rPr sz="2000" b="1" i="0">
@@ -7831,7 +8810,7 @@
                 </a:solidFill>
                 <a:latin typeface="Calibri"/>
               </a:rPr>
-              <a:t>Demo:</a:t>
+              <a:t>DDL real</a:t>
             </a:r>
             <a:r>
               <a:rPr sz="2000" b="0" i="0">
@@ -7840,7 +8819,7 @@
                 </a:solidFill>
                 <a:latin typeface="Calibri"/>
               </a:rPr>
-              <a:t> Recorrido de checklist + ejemplo demo de 3 min.</a:t>
+              <a:t>, en los dos sentidos.</a:t>
             </a:r>
           </a:p>
           <a:p>
@@ -7856,15 +8835,17 @@
                 </a:solidFill>
                 <a:latin typeface="Calibri"/>
               </a:rPr>
-              <a:t>–   Sigan el mismo dominio de la clínica (no inventen otro caso).</a:t>
-            </a:r>
-          </a:p>
-          <a:p>
-            <a:pPr>
-              <a:spcAft>
-                <a:spcPts val="800"/>
-              </a:spcAft>
-            </a:pPr>
+              <a:t>–   Cada hallazgo se escribe con sus </a:t>
+            </a:r>
+            <a:r>
+              <a:rPr sz="2000" b="1" i="0">
+                <a:solidFill>
+                  <a:srgbClr val="333333"/>
+                </a:solidFill>
+                <a:latin typeface="Calibri"/>
+              </a:rPr>
+              <a:t>cinco partes</a:t>
+            </a:r>
             <a:r>
               <a:rPr sz="2000" b="0" i="0">
                 <a:solidFill>
@@ -7872,66 +8853,14 @@
                 </a:solidFill>
                 <a:latin typeface="Calibri"/>
               </a:rPr>
-              <a:t>–   </a:t>
-            </a:r>
-            <a:r>
-              <a:rPr sz="2000" b="1" i="0">
-                <a:solidFill>
-                  <a:srgbClr val="333333"/>
-                </a:solidFill>
-                <a:latin typeface="Calibri"/>
-              </a:rPr>
-              <a:t>Qué observar:</a:t>
-            </a:r>
-            <a:r>
-              <a:rPr sz="2000" b="0" i="0">
-                <a:solidFill>
-                  <a:srgbClr val="333333"/>
-                </a:solidFill>
-                <a:latin typeface="Calibri"/>
-              </a:rPr>
-              <a:t> cada hallazgo se demuestra con una ejecucion: el DDL contra el ER y el procedimiento con un caso valido y uno invalido.</a:t>
-            </a:r>
-          </a:p>
-          <a:p>
-            <a:pPr>
-              <a:spcAft>
-                <a:spcPts val="800"/>
-              </a:spcAft>
-            </a:pPr>
-            <a:r>
-              <a:rPr sz="2000" b="0" i="0">
-                <a:solidFill>
-                  <a:srgbClr val="333333"/>
-                </a:solidFill>
-                <a:latin typeface="Calibri"/>
-              </a:rPr>
-              <a:t>–   </a:t>
-            </a:r>
-            <a:r>
-              <a:rPr sz="2000" b="1" i="0">
-                <a:solidFill>
-                  <a:srgbClr val="333333"/>
-                </a:solidFill>
-                <a:latin typeface="Calibri"/>
-              </a:rPr>
-              <a:t>Qué observar:</a:t>
-            </a:r>
-            <a:r>
-              <a:rPr sz="2000" b="0" i="0">
-                <a:solidFill>
-                  <a:srgbClr val="333333"/>
-                </a:solidFill>
-                <a:latin typeface="Calibri"/>
-              </a:rPr>
-              <a:t> un hallazgo util nombra el artefacto, el problema, su impacto en la clínica y la accion concreta que lo corrige.</a:t>
-            </a:r>
-          </a:p>
-        </p:txBody>
-      </p:sp>
-      <p:sp>
-        <p:nvSpPr>
-          <p:cNvPr id="6" name="TextBox 5"/>
+              <a:t>: artefacto, observación, impacto, acción y responsable.</a:t>
+            </a:r>
+          </a:p>
+        </p:txBody>
+      </p:sp>
+      <p:sp>
+        <p:nvSpPr>
+          <p:cNvPr id="8" name="TextBox 7"/>
           <p:cNvSpPr txBox="1"/>
           <p:nvPr/>
         </p:nvSpPr>
@@ -9293,7 +10222,7 @@
                 </a:solidFill>
                 <a:latin typeface="Calibri"/>
               </a:rPr>
-              <a:t> Avance proyecto · la base de la clínica</a:t>
+              <a:t> la revisión técnica del avance de la base de la clínica.</a:t>
             </a:r>
           </a:p>
           <a:p>
@@ -9318,7 +10247,7 @@
                 </a:solidFill>
                 <a:latin typeface="Calibri"/>
               </a:rPr>
-              <a:t>Live SQL / DB Fiddle + draw.io</a:t>
+              <a:t>PostgreSQL en el navegador</a:t>
             </a:r>
             <a:r>
               <a:rPr sz="2000" b="0" i="0">
@@ -9327,7 +10256,7 @@
                 </a:solidFill>
                 <a:latin typeface="Calibri"/>
               </a:rPr>
-              <a:t> · Bloque </a:t>
+              <a:t> y un editor de diagramas · Bloque </a:t>
             </a:r>
             <a:r>
               <a:rPr sz="2000" b="1" i="0">
@@ -9352,7 +10281,7 @@
                 </a:solidFill>
                 <a:latin typeface="Calibri"/>
               </a:rPr>
-              <a:t>–   Gratis + navegador · free tier · sin software de pago obligatorio.</a:t>
+              <a:t>–   Gratis + navegador · sin software de pago obligatorio.</a:t>
             </a:r>
           </a:p>
           <a:p>
@@ -9418,7 +10347,7 @@
                 </a:solidFill>
                 <a:latin typeface="Calibri"/>
               </a:rPr>
-              <a:t> Que es una revision tecnica, y con que producto se sale · Lo que se audita es la coherencia entre piezas · Verificaciones uno y dos · Verificacion tres.</a:t>
+              <a:t> revisión técnica · coherencia entre piezas · verificaciones cruzadas · control del alcance · el hallazgo útil.</a:t>
             </a:r>
           </a:p>
         </p:txBody>
@@ -10573,9 +11502,33 @@
           </a:prstGeom>
         </p:spPr>
       </p:pic>
-      <p:sp>
-        <p:nvSpPr>
-          <p:cNvPr id="13" name="TextBox 12"/>
+      <p:pic>
+        <p:nvPicPr>
+          <p:cNvPr id="9" name="Picture 8" descr="revision-roles-paso4.png"/>
+          <p:cNvPicPr>
+            <a:picLocks noChangeAspect="1"/>
+          </p:cNvPicPr>
+          <p:nvPr/>
+        </p:nvPicPr>
+        <p:blipFill>
+          <a:blip r:embed="rId5"/>
+          <a:stretch>
+            <a:fillRect/>
+          </a:stretch>
+        </p:blipFill>
+        <p:spPr>
+          <a:xfrm>
+            <a:off x="5876318" y="1261872"/>
+            <a:ext cx="5852160" cy="4681728"/>
+          </a:xfrm>
+          <a:prstGeom prst="rect">
+            <a:avLst/>
+          </a:prstGeom>
+        </p:spPr>
+      </p:pic>
+      <p:sp>
+        <p:nvSpPr>
+          <p:cNvPr id="18" name="TextBox 17"/>
           <p:cNvSpPr txBox="1"/>
           <p:nvPr/>
         </p:nvSpPr>
@@ -10610,7 +11563,7 @@
       </p:sp>
       <p:sp>
         <p:nvSpPr>
-          <p:cNvPr id="14" name="TextBox 13"/>
+          <p:cNvPr id="19" name="TextBox 18"/>
           <p:cNvSpPr txBox="1"/>
           <p:nvPr/>
         </p:nvSpPr>
@@ -10642,7 +11595,25 @@
                 </a:solidFill>
                 <a:latin typeface="Calibri"/>
               </a:rPr>
-              <a:t>–   Una revision tecnica es una reunion con un proposito unico: encontrar defectos en un artefacto antes de que cuesten caro, y salir con un producto…</a:t>
+              <a:t>–   Una </a:t>
+            </a:r>
+            <a:r>
+              <a:rPr sz="2000" b="1" i="0">
+                <a:solidFill>
+                  <a:srgbClr val="333333"/>
+                </a:solidFill>
+                <a:latin typeface="Calibri"/>
+              </a:rPr>
+              <a:t>revisión técnica</a:t>
+            </a:r>
+            <a:r>
+              <a:rPr sz="2000" b="0" i="0">
+                <a:solidFill>
+                  <a:srgbClr val="333333"/>
+                </a:solidFill>
+                <a:latin typeface="Calibri"/>
+              </a:rPr>
+              <a:t> busca defectos en un artefacto antes de que cuesten caro.</a:t>
             </a:r>
           </a:p>
           <a:p>
@@ -10658,7 +11629,79 @@
                 </a:solidFill>
                 <a:latin typeface="Calibri"/>
               </a:rPr>
-              <a:t>–   No es una reunion de avance, no es una calificacion y no es una demostracion para lucirse.</a:t>
+              <a:t>–   Tiene cuatro roles: </a:t>
+            </a:r>
+            <a:r>
+              <a:rPr sz="2000" b="1" i="0">
+                <a:solidFill>
+                  <a:srgbClr val="333333"/>
+                </a:solidFill>
+                <a:latin typeface="Calibri"/>
+              </a:rPr>
+              <a:t>autor</a:t>
+            </a:r>
+            <a:r>
+              <a:rPr sz="2000" b="0" i="0">
+                <a:solidFill>
+                  <a:srgbClr val="333333"/>
+                </a:solidFill>
+                <a:latin typeface="Calibri"/>
+              </a:rPr>
+              <a:t> presenta, </a:t>
+            </a:r>
+            <a:r>
+              <a:rPr sz="2000" b="1" i="0">
+                <a:solidFill>
+                  <a:srgbClr val="333333"/>
+                </a:solidFill>
+                <a:latin typeface="Calibri"/>
+              </a:rPr>
+              <a:t>revisores</a:t>
+            </a:r>
+            <a:r>
+              <a:rPr sz="2000" b="0" i="0">
+                <a:solidFill>
+                  <a:srgbClr val="333333"/>
+                </a:solidFill>
+                <a:latin typeface="Calibri"/>
+              </a:rPr>
+              <a:t> buscan, </a:t>
+            </a:r>
+            <a:r>
+              <a:rPr sz="2000" b="1" i="0">
+                <a:solidFill>
+                  <a:srgbClr val="333333"/>
+                </a:solidFill>
+                <a:latin typeface="Calibri"/>
+              </a:rPr>
+              <a:t>moderador</a:t>
+            </a:r>
+            <a:r>
+              <a:rPr sz="2000" b="0" i="0">
+                <a:solidFill>
+                  <a:srgbClr val="333333"/>
+                </a:solidFill>
+                <a:latin typeface="Calibri"/>
+              </a:rPr>
+              <a:t> cuida el tiempo y </a:t>
+            </a:r>
+            <a:r>
+              <a:rPr sz="2000" b="1" i="0">
+                <a:solidFill>
+                  <a:srgbClr val="333333"/>
+                </a:solidFill>
+                <a:latin typeface="Calibri"/>
+              </a:rPr>
+              <a:t>escriba</a:t>
+            </a:r>
+            <a:r>
+              <a:rPr sz="2000" b="0" i="0">
+                <a:solidFill>
+                  <a:srgbClr val="333333"/>
+                </a:solidFill>
+                <a:latin typeface="Calibri"/>
+              </a:rPr>
+              <a:t> registra.</a:t>
             </a:r>
           </a:p>
           <a:p>
@@ -10674,7 +11717,25 @@
                 </a:solidFill>
                 <a:latin typeface="Calibri"/>
               </a:rPr>
-              <a:t>–   La practica tiene nombres y roles establecidos desde hace decadas en ingenieria de software.</a:t>
+              <a:t>–   Se sale con un producto escrito, el </a:t>
+            </a:r>
+            <a:r>
+              <a:rPr sz="2000" b="1" i="0">
+                <a:solidFill>
+                  <a:srgbClr val="333333"/>
+                </a:solidFill>
+                <a:latin typeface="Calibri"/>
+              </a:rPr>
+              <a:t>acta de hallazgos</a:t>
+            </a:r>
+            <a:r>
+              <a:rPr sz="2000" b="0" i="0">
+                <a:solidFill>
+                  <a:srgbClr val="333333"/>
+                </a:solidFill>
+                <a:latin typeface="Calibri"/>
+              </a:rPr>
+              <a:t>, no con una nota ni con un aplauso.</a:t>
             </a:r>
           </a:p>
           <a:p>
@@ -10690,14 +11751,32 @@
                 </a:solidFill>
                 <a:latin typeface="Calibri"/>
               </a:rPr>
-              <a:t>–   El estandar clasico, IEEE 1028, distingue la inspeccion (formal.</a:t>
-            </a:r>
-          </a:p>
-        </p:txBody>
-      </p:sp>
-      <p:sp>
-        <p:nvSpPr>
-          <p:cNvPr id="15" name="TextBox 14"/>
+              <a:t>–   Se revisa el </a:t>
+            </a:r>
+            <a:r>
+              <a:rPr sz="2000" b="1" i="0">
+                <a:solidFill>
+                  <a:srgbClr val="333333"/>
+                </a:solidFill>
+                <a:latin typeface="Calibri"/>
+              </a:rPr>
+              <a:t>artefacto</a:t>
+            </a:r>
+            <a:r>
+              <a:rPr sz="2000" b="0" i="0">
+                <a:solidFill>
+                  <a:srgbClr val="333333"/>
+                </a:solidFill>
+                <a:latin typeface="Calibri"/>
+              </a:rPr>
+              <a:t>, no la persona, y el problema se registra, no se arregla en la reunión.</a:t>
+            </a:r>
+          </a:p>
+        </p:txBody>
+      </p:sp>
+      <p:sp>
+        <p:nvSpPr>
+          <p:cNvPr id="20" name="TextBox 19"/>
           <p:cNvSpPr txBox="1"/>
           <p:nvPr/>
         </p:nvSpPr>
@@ -10849,6 +11928,59 @@
                       </p:childTnLst>
                     </p:cTn>
                   </p:par>
+                  <p:par>
+                    <p:cTn id="13" fill="hold">
+                      <p:stCondLst>
+                        <p:cond delay="indefinite"/>
+                      </p:stCondLst>
+                      <p:childTnLst>
+                        <p:par>
+                          <p:cTn id="14" fill="hold">
+                            <p:stCondLst>
+                              <p:cond delay="0"/>
+                            </p:stCondLst>
+                            <p:childTnLst>
+                              <p:par>
+                                <p:cTn id="15" presetID="10" presetClass="entr" presetSubtype="0" fill="hold" nodeType="clickEffect">
+                                  <p:stCondLst>
+                                    <p:cond delay="0"/>
+                                  </p:stCondLst>
+                                  <p:childTnLst>
+                                    <p:set>
+                                      <p:cBhvr>
+                                        <p:cTn id="16" dur="1" fill="hold">
+                                          <p:stCondLst>
+                                            <p:cond delay="0"/>
+                                          </p:stCondLst>
+                                        </p:cTn>
+                                        <p:tgtEl>
+                                          <p:spTgt spid="9"/>
+                                        </p:tgtEl>
+                                        <p:attrNameLst>
+                                          <p:attrName>style.visibility</p:attrName>
+                                        </p:attrNameLst>
+                                      </p:cBhvr>
+                                      <p:to>
+                                        <p:strVal val="visible"/>
+                                      </p:to>
+                                    </p:set>
+                                    <p:animEffect transition="in" filter="fade">
+                                      <p:cBhvr>
+                                        <p:cTn id="17" dur="450"/>
+                                        <p:tgtEl>
+                                          <p:spTgt spid="9"/>
+                                        </p:tgtEl>
+                                      </p:cBhvr>
+                                    </p:animEffect>
+                                  </p:childTnLst>
+                                </p:cTn>
+                              </p:par>
+                            </p:childTnLst>
+                          </p:cTn>
+                        </p:par>
+                      </p:childTnLst>
+                    </p:cTn>
+                  </p:par>
                 </p:childTnLst>
               </p:cTn>
               <p:prevCondLst>
@@ -11129,9 +12261,33 @@
           </a:prstGeom>
         </p:spPr>
       </p:pic>
-      <p:sp>
-        <p:nvSpPr>
-          <p:cNvPr id="13" name="TextBox 12"/>
+      <p:pic>
+        <p:nvPicPr>
+          <p:cNvPr id="9" name="Picture 8" descr="coherencia-piezas-paso4.png"/>
+          <p:cNvPicPr>
+            <a:picLocks noChangeAspect="1"/>
+          </p:cNvPicPr>
+          <p:nvPr/>
+        </p:nvPicPr>
+        <p:blipFill>
+          <a:blip r:embed="rId5"/>
+          <a:stretch>
+            <a:fillRect/>
+          </a:stretch>
+        </p:blipFill>
+        <p:spPr>
+          <a:xfrm>
+            <a:off x="5876318" y="1261872"/>
+            <a:ext cx="5852160" cy="4681728"/>
+          </a:xfrm>
+          <a:prstGeom prst="rect">
+            <a:avLst/>
+          </a:prstGeom>
+        </p:spPr>
+      </p:pic>
+      <p:sp>
+        <p:nvSpPr>
+          <p:cNvPr id="18" name="TextBox 17"/>
           <p:cNvSpPr txBox="1"/>
           <p:nvPr/>
         </p:nvSpPr>
@@ -11166,7 +12322,7 @@
       </p:sp>
       <p:sp>
         <p:nvSpPr>
-          <p:cNvPr id="14" name="TextBox 13"/>
+          <p:cNvPr id="19" name="TextBox 18"/>
           <p:cNvSpPr txBox="1"/>
           <p:nvPr/>
         </p:nvSpPr>
@@ -11198,7 +12354,25 @@
                 </a:solidFill>
                 <a:latin typeface="Calibri"/>
               </a:rPr>
-              <a:t>–   Un artefacto es cualquier producto de trabajo: el diagrama entidad-relacion, el script DDL, la matriz de roles, los procedimientos, el informe de…</a:t>
+              <a:t>–   Un </a:t>
+            </a:r>
+            <a:r>
+              <a:rPr sz="2000" b="1" i="0">
+                <a:solidFill>
+                  <a:srgbClr val="333333"/>
+                </a:solidFill>
+                <a:latin typeface="Calibri"/>
+              </a:rPr>
+              <a:t>artefacto</a:t>
+            </a:r>
+            <a:r>
+              <a:rPr sz="2000" b="0" i="0">
+                <a:solidFill>
+                  <a:srgbClr val="333333"/>
+                </a:solidFill>
+                <a:latin typeface="Calibri"/>
+              </a:rPr>
+              <a:t> es cualquier producto de trabajo: el ER, el DDL, la matriz de roles, los procedimientos, el informe.</a:t>
             </a:r>
           </a:p>
           <a:p>
@@ -11214,7 +12388,25 @@
                 </a:solidFill>
                 <a:latin typeface="Calibri"/>
               </a:rPr>
-              <a:t>–   Es perfectamente posible que un estudiante tenga un ER bien dibujado, un DDL que ejecuta sin errores</a:t>
+              <a:t>–   Cada pieza puede estar bien sola y aun así describir, junto a otra, </a:t>
+            </a:r>
+            <a:r>
+              <a:rPr sz="2000" b="1" i="0">
+                <a:solidFill>
+                  <a:srgbClr val="333333"/>
+                </a:solidFill>
+                <a:latin typeface="Calibri"/>
+              </a:rPr>
+              <a:t>bases distintas</a:t>
+            </a:r>
+            <a:r>
+              <a:rPr sz="2000" b="0" i="0">
+                <a:solidFill>
+                  <a:srgbClr val="333333"/>
+                </a:solidFill>
+                <a:latin typeface="Calibri"/>
+              </a:rPr>
+              <a:t>.</a:t>
             </a:r>
           </a:p>
           <a:p>
@@ -11230,14 +12422,66 @@
                 </a:solidFill>
                 <a:latin typeface="Calibri"/>
               </a:rPr>
-              <a:t>–   Y que ambos describan bases de datos distintas, porque el ER se dibujo en la Clase 1 y el DDL se fue parchando en las Clases 3 a 8 sin volver a…</a:t>
-            </a:r>
-          </a:p>
-        </p:txBody>
-      </p:sp>
-      <p:sp>
-        <p:nvSpPr>
-          <p:cNvPr id="15" name="TextBox 14"/>
+              <a:t>–   El caso más común: el ER se dibujó al inicio y el DDL se fue </a:t>
+            </a:r>
+            <a:r>
+              <a:rPr sz="2000" b="1" i="0">
+                <a:solidFill>
+                  <a:srgbClr val="333333"/>
+                </a:solidFill>
+                <a:latin typeface="Calibri"/>
+              </a:rPr>
+              <a:t>parchando</a:t>
+            </a:r>
+            <a:r>
+              <a:rPr sz="2000" b="0" i="0">
+                <a:solidFill>
+                  <a:srgbClr val="333333"/>
+                </a:solidFill>
+                <a:latin typeface="Calibri"/>
+              </a:rPr>
+              <a:t> sin actualizarlo.</a:t>
+            </a:r>
+          </a:p>
+          <a:p>
+            <a:pPr>
+              <a:spcAft>
+                <a:spcPts val="800"/>
+              </a:spcAft>
+            </a:pPr>
+            <a:r>
+              <a:rPr sz="2000" b="0" i="0">
+                <a:solidFill>
+                  <a:srgbClr val="333333"/>
+                </a:solidFill>
+                <a:latin typeface="Calibri"/>
+              </a:rPr>
+              <a:t>–   Por eso se corren </a:t>
+            </a:r>
+            <a:r>
+              <a:rPr sz="2000" b="1" i="0">
+                <a:solidFill>
+                  <a:srgbClr val="333333"/>
+                </a:solidFill>
+                <a:latin typeface="Calibri"/>
+              </a:rPr>
+              <a:t>cuatro verificaciones cruzadas</a:t>
+            </a:r>
+            <a:r>
+              <a:rPr sz="2000" b="0" i="0">
+                <a:solidFill>
+                  <a:srgbClr val="333333"/>
+                </a:solidFill>
+                <a:latin typeface="Calibri"/>
+              </a:rPr>
+              <a:t>, cada una entre dos piezas.</a:t>
+            </a:r>
+          </a:p>
+        </p:txBody>
+      </p:sp>
+      <p:sp>
+        <p:nvSpPr>
+          <p:cNvPr id="20" name="TextBox 19"/>
           <p:cNvSpPr txBox="1"/>
           <p:nvPr/>
         </p:nvSpPr>
@@ -11389,6 +12633,59 @@
                       </p:childTnLst>
                     </p:cTn>
                   </p:par>
+                  <p:par>
+                    <p:cTn id="13" fill="hold">
+                      <p:stCondLst>
+                        <p:cond delay="indefinite"/>
+                      </p:stCondLst>
+                      <p:childTnLst>
+                        <p:par>
+                          <p:cTn id="14" fill="hold">
+                            <p:stCondLst>
+                              <p:cond delay="0"/>
+                            </p:stCondLst>
+                            <p:childTnLst>
+                              <p:par>
+                                <p:cTn id="15" presetID="10" presetClass="entr" presetSubtype="0" fill="hold" nodeType="clickEffect">
+                                  <p:stCondLst>
+                                    <p:cond delay="0"/>
+                                  </p:stCondLst>
+                                  <p:childTnLst>
+                                    <p:set>
+                                      <p:cBhvr>
+                                        <p:cTn id="16" dur="1" fill="hold">
+                                          <p:stCondLst>
+                                            <p:cond delay="0"/>
+                                          </p:stCondLst>
+                                        </p:cTn>
+                                        <p:tgtEl>
+                                          <p:spTgt spid="9"/>
+                                        </p:tgtEl>
+                                        <p:attrNameLst>
+                                          <p:attrName>style.visibility</p:attrName>
+                                        </p:attrNameLst>
+                                      </p:cBhvr>
+                                      <p:to>
+                                        <p:strVal val="visible"/>
+                                      </p:to>
+                                    </p:set>
+                                    <p:animEffect transition="in" filter="fade">
+                                      <p:cBhvr>
+                                        <p:cTn id="17" dur="450"/>
+                                        <p:tgtEl>
+                                          <p:spTgt spid="9"/>
+                                        </p:tgtEl>
+                                      </p:cBhvr>
+                                    </p:animEffect>
+                                  </p:childTnLst>
+                                </p:cTn>
+                              </p:par>
+                            </p:childTnLst>
+                          </p:cTn>
+                        </p:par>
+                      </p:childTnLst>
+                    </p:cTn>
+                  </p:par>
                 </p:childTnLst>
               </p:cTn>
               <p:prevCondLst>
@@ -11669,9 +12966,33 @@
           </a:prstGeom>
         </p:spPr>
       </p:pic>
-      <p:sp>
-        <p:nvSpPr>
-          <p:cNvPr id="13" name="TextBox 12"/>
+      <p:pic>
+        <p:nvPicPr>
+          <p:cNvPr id="9" name="Picture 8" descr="er-contra-ddl-paso4.png"/>
+          <p:cNvPicPr>
+            <a:picLocks noChangeAspect="1"/>
+          </p:cNvPicPr>
+          <p:nvPr/>
+        </p:nvPicPr>
+        <p:blipFill>
+          <a:blip r:embed="rId5"/>
+          <a:stretch>
+            <a:fillRect/>
+          </a:stretch>
+        </p:blipFill>
+        <p:spPr>
+          <a:xfrm>
+            <a:off x="5876318" y="1261872"/>
+            <a:ext cx="5852160" cy="4681728"/>
+          </a:xfrm>
+          <a:prstGeom prst="rect">
+            <a:avLst/>
+          </a:prstGeom>
+        </p:spPr>
+      </p:pic>
+      <p:sp>
+        <p:nvSpPr>
+          <p:cNvPr id="18" name="TextBox 17"/>
           <p:cNvSpPr txBox="1"/>
           <p:nvPr/>
         </p:nvSpPr>
@@ -11706,7 +13027,7 @@
       </p:sp>
       <p:sp>
         <p:nvSpPr>
-          <p:cNvPr id="14" name="TextBox 13"/>
+          <p:cNvPr id="19" name="TextBox 18"/>
           <p:cNvSpPr txBox="1"/>
           <p:nvPr/>
         </p:nvSpPr>
@@ -11738,7 +13059,25 @@
                 </a:solidFill>
                 <a:latin typeface="Calibri"/>
               </a:rPr>
-              <a:t>–   Se recorre el diagrama entidad por entidad y se busca su CREATE TABLE: toda entidad sin tabla es un hallazgo.</a:t>
+              <a:t>–   De ida, cada entidad del ER debe tener su CREATE TABLE: una </a:t>
+            </a:r>
+            <a:r>
+              <a:rPr sz="2000" b="1" i="0">
+                <a:solidFill>
+                  <a:srgbClr val="333333"/>
+                </a:solidFill>
+                <a:latin typeface="Calibri"/>
+              </a:rPr>
+              <a:t>entidad sin tabla</a:t>
+            </a:r>
+            <a:r>
+              <a:rPr sz="2000" b="0" i="0">
+                <a:solidFill>
+                  <a:srgbClr val="333333"/>
+                </a:solidFill>
+                <a:latin typeface="Calibri"/>
+              </a:rPr>
+              <a:t> es un hallazgo.</a:t>
             </a:r>
           </a:p>
           <a:p>
@@ -11754,7 +13093,25 @@
                 </a:solidFill>
                 <a:latin typeface="Calibri"/>
               </a:rPr>
-              <a:t>–   Luego se recorre en sentido contrario, porque es el que nadie hace.</a:t>
+              <a:t>–   De vuelta, una </a:t>
+            </a:r>
+            <a:r>
+              <a:rPr sz="2000" b="1" i="0">
+                <a:solidFill>
+                  <a:srgbClr val="333333"/>
+                </a:solidFill>
+                <a:latin typeface="Calibri"/>
+              </a:rPr>
+              <a:t>tabla sin entidad</a:t>
+            </a:r>
+            <a:r>
+              <a:rPr sz="2000" b="0" i="0">
+                <a:solidFill>
+                  <a:srgbClr val="333333"/>
+                </a:solidFill>
+                <a:latin typeface="Calibri"/>
+              </a:rPr>
+              <a:t> también lo es, y es la revisión que casi nadie hace.</a:t>
             </a:r>
           </a:p>
           <a:p>
@@ -11770,14 +13127,66 @@
                 </a:solidFill>
                 <a:latin typeface="Calibri"/>
               </a:rPr>
-              <a:t>–   Si el ER dice que una cita pertenece a exactamente una mascota, el DDL debe tener id_mascota con NOT NULL y una FOREIGN KEY hacia Mascota</a:t>
-            </a:r>
-          </a:p>
-        </p:txBody>
-      </p:sp>
-      <p:sp>
-        <p:nvSpPr>
-          <p:cNvPr id="15" name="TextBox 14"/>
+              <a:t>–   Una cardinalidad dibujada debe existir como </a:t>
+            </a:r>
+            <a:r>
+              <a:rPr sz="2000" b="1" i="0">
+                <a:solidFill>
+                  <a:srgbClr val="333333"/>
+                </a:solidFill>
+                <a:latin typeface="Calibri"/>
+              </a:rPr>
+              <a:t>NOT NULL y REFERENCES</a:t>
+            </a:r>
+            <a:r>
+              <a:rPr sz="2000" b="0" i="0">
+                <a:solidFill>
+                  <a:srgbClr val="333333"/>
+                </a:solidFill>
+                <a:latin typeface="Calibri"/>
+              </a:rPr>
+              <a:t> en el DDL.</a:t>
+            </a:r>
+          </a:p>
+          <a:p>
+            <a:pPr>
+              <a:spcAft>
+                <a:spcPts val="800"/>
+              </a:spcAft>
+            </a:pPr>
+            <a:r>
+              <a:rPr sz="2000" b="0" i="0">
+                <a:solidFill>
+                  <a:srgbClr val="333333"/>
+                </a:solidFill>
+                <a:latin typeface="Calibri"/>
+              </a:rPr>
+              <a:t>–   Verificación dos: cada celda de la </a:t>
+            </a:r>
+            <a:r>
+              <a:rPr sz="2000" b="1" i="0">
+                <a:solidFill>
+                  <a:srgbClr val="333333"/>
+                </a:solidFill>
+                <a:latin typeface="Calibri"/>
+              </a:rPr>
+              <a:t>matriz de roles</a:t>
+            </a:r>
+            <a:r>
+              <a:rPr sz="2000" b="0" i="0">
+                <a:solidFill>
+                  <a:srgbClr val="333333"/>
+                </a:solidFill>
+                <a:latin typeface="Calibri"/>
+              </a:rPr>
+              <a:t> debe verse en un GRANT, y nada más.</a:t>
+            </a:r>
+          </a:p>
+        </p:txBody>
+      </p:sp>
+      <p:sp>
+        <p:nvSpPr>
+          <p:cNvPr id="20" name="TextBox 19"/>
           <p:cNvSpPr txBox="1"/>
           <p:nvPr/>
         </p:nvSpPr>
@@ -11929,6 +13338,59 @@
                       </p:childTnLst>
                     </p:cTn>
                   </p:par>
+                  <p:par>
+                    <p:cTn id="13" fill="hold">
+                      <p:stCondLst>
+                        <p:cond delay="indefinite"/>
+                      </p:stCondLst>
+                      <p:childTnLst>
+                        <p:par>
+                          <p:cTn id="14" fill="hold">
+                            <p:stCondLst>
+                              <p:cond delay="0"/>
+                            </p:stCondLst>
+                            <p:childTnLst>
+                              <p:par>
+                                <p:cTn id="15" presetID="10" presetClass="entr" presetSubtype="0" fill="hold" nodeType="clickEffect">
+                                  <p:stCondLst>
+                                    <p:cond delay="0"/>
+                                  </p:stCondLst>
+                                  <p:childTnLst>
+                                    <p:set>
+                                      <p:cBhvr>
+                                        <p:cTn id="16" dur="1" fill="hold">
+                                          <p:stCondLst>
+                                            <p:cond delay="0"/>
+                                          </p:stCondLst>
+                                        </p:cTn>
+                                        <p:tgtEl>
+                                          <p:spTgt spid="9"/>
+                                        </p:tgtEl>
+                                        <p:attrNameLst>
+                                          <p:attrName>style.visibility</p:attrName>
+                                        </p:attrNameLst>
+                                      </p:cBhvr>
+                                      <p:to>
+                                        <p:strVal val="visible"/>
+                                      </p:to>
+                                    </p:set>
+                                    <p:animEffect transition="in" filter="fade">
+                                      <p:cBhvr>
+                                        <p:cTn id="17" dur="450"/>
+                                        <p:tgtEl>
+                                          <p:spTgt spid="9"/>
+                                        </p:tgtEl>
+                                      </p:cBhvr>
+                                    </p:animEffect>
+                                  </p:childTnLst>
+                                </p:cTn>
+                              </p:par>
+                            </p:childTnLst>
+                          </p:cTn>
+                        </p:par>
+                      </p:childTnLst>
+                    </p:cTn>
+                  </p:par>
                 </p:childTnLst>
               </p:cTn>
               <p:prevCondLst>
@@ -12209,9 +13671,33 @@
           </a:prstGeom>
         </p:spPr>
       </p:pic>
-      <p:sp>
-        <p:nvSpPr>
-          <p:cNvPr id="13" name="TextBox 12"/>
+      <p:pic>
+        <p:nvPicPr>
+          <p:cNvPr id="9" name="Picture 8" descr="compila-funciona-paso4.png"/>
+          <p:cNvPicPr>
+            <a:picLocks noChangeAspect="1"/>
+          </p:cNvPicPr>
+          <p:nvPr/>
+        </p:nvPicPr>
+        <p:blipFill>
+          <a:blip r:embed="rId5"/>
+          <a:stretch>
+            <a:fillRect/>
+          </a:stretch>
+        </p:blipFill>
+        <p:spPr>
+          <a:xfrm>
+            <a:off x="5876318" y="1261872"/>
+            <a:ext cx="5852160" cy="4681728"/>
+          </a:xfrm>
+          <a:prstGeom prst="rect">
+            <a:avLst/>
+          </a:prstGeom>
+        </p:spPr>
+      </p:pic>
+      <p:sp>
+        <p:nvSpPr>
+          <p:cNvPr id="18" name="TextBox 17"/>
           <p:cNvSpPr txBox="1"/>
           <p:nvPr/>
         </p:nvSpPr>
@@ -12246,7 +13732,7 @@
       </p:sp>
       <p:sp>
         <p:nvSpPr>
-          <p:cNvPr id="14" name="TextBox 13"/>
+          <p:cNvPr id="19" name="TextBox 18"/>
           <p:cNvSpPr txBox="1"/>
           <p:nvPr/>
         </p:nvSpPr>
@@ -12278,7 +13764,43 @@
                 </a:solidFill>
                 <a:latin typeface="Calibri"/>
               </a:rPr>
-              <a:t>–   La distincion que separa a un estudiante que va bien de uno que va mal es esta: un procedimiento que compila no es un procedimiento que funciona.</a:t>
+              <a:t>–   Un procedimiento que </a:t>
+            </a:r>
+            <a:r>
+              <a:rPr sz="2000" b="1" i="0">
+                <a:solidFill>
+                  <a:srgbClr val="333333"/>
+                </a:solidFill>
+                <a:latin typeface="Calibri"/>
+              </a:rPr>
+              <a:t>compila</a:t>
+            </a:r>
+            <a:r>
+              <a:rPr sz="2000" b="0" i="0">
+                <a:solidFill>
+                  <a:srgbClr val="333333"/>
+                </a:solidFill>
+                <a:latin typeface="Calibri"/>
+              </a:rPr>
+              <a:t> no es un procedimiento que </a:t>
+            </a:r>
+            <a:r>
+              <a:rPr sz="2000" b="1" i="0">
+                <a:solidFill>
+                  <a:srgbClr val="333333"/>
+                </a:solidFill>
+                <a:latin typeface="Calibri"/>
+              </a:rPr>
+              <a:t>funciona</a:t>
+            </a:r>
+            <a:r>
+              <a:rPr sz="2000" b="0" i="0">
+                <a:solidFill>
+                  <a:srgbClr val="333333"/>
+                </a:solidFill>
+                <a:latin typeface="Calibri"/>
+              </a:rPr>
+              <a:t>: se piden dos ejecuciones.</a:t>
             </a:r>
           </a:p>
           <a:p>
@@ -12294,7 +13816,43 @@
                 </a:solidFill>
                 <a:latin typeface="Calibri"/>
               </a:rPr>
-              <a:t>–   Primero CALL sp_agendar_cita con datos validos, que debe insertar la cita y devolver confirmacion.</a:t>
+              <a:t>–   El </a:t>
+            </a:r>
+            <a:r>
+              <a:rPr sz="2000" b="1" i="0">
+                <a:solidFill>
+                  <a:srgbClr val="333333"/>
+                </a:solidFill>
+                <a:latin typeface="Calibri"/>
+              </a:rPr>
+              <a:t>caso válido</a:t>
+            </a:r>
+            <a:r>
+              <a:rPr sz="2000" b="0" i="0">
+                <a:solidFill>
+                  <a:srgbClr val="333333"/>
+                </a:solidFill>
+                <a:latin typeface="Calibri"/>
+              </a:rPr>
+              <a:t> inserta la cita, y el </a:t>
+            </a:r>
+            <a:r>
+              <a:rPr sz="2000" b="1" i="0">
+                <a:solidFill>
+                  <a:srgbClr val="333333"/>
+                </a:solidFill>
+                <a:latin typeface="Calibri"/>
+              </a:rPr>
+              <a:t>caso inválido</a:t>
+            </a:r>
+            <a:r>
+              <a:rPr sz="2000" b="0" i="0">
+                <a:solidFill>
+                  <a:srgbClr val="333333"/>
+                </a:solidFill>
+                <a:latin typeface="Calibri"/>
+              </a:rPr>
+              <a:t> declarado responde con su mensaje de negocio.</a:t>
             </a:r>
           </a:p>
           <a:p>
@@ -12310,7 +13868,25 @@
                 </a:solidFill>
                 <a:latin typeface="Calibri"/>
               </a:rPr>
-              <a:t>–   Segundo, CALL sp_agendar_cita con el caso invalido que el propio estudiante declaro, es decir una mascota inactiva o un horario ya tomado.</a:t>
+              <a:t>–   Verificación cuatro: una optimización se demuestra con el </a:t>
+            </a:r>
+            <a:r>
+              <a:rPr sz="2000" b="1" i="0">
+                <a:solidFill>
+                  <a:srgbClr val="333333"/>
+                </a:solidFill>
+                <a:latin typeface="Calibri"/>
+              </a:rPr>
+              <a:t>plan antes y después</a:t>
+            </a:r>
+            <a:r>
+              <a:rPr sz="2000" b="0" i="0">
+                <a:solidFill>
+                  <a:srgbClr val="333333"/>
+                </a:solidFill>
+                <a:latin typeface="Calibri"/>
+              </a:rPr>
+              <a:t>.</a:t>
             </a:r>
           </a:p>
           <a:p>
@@ -12326,14 +13902,32 @@
                 </a:solidFill>
                 <a:latin typeface="Calibri"/>
               </a:rPr>
-              <a:t>–   Si el estudiante no puede mostrar la segunda ejecucion.</a:t>
-            </a:r>
-          </a:p>
-        </p:txBody>
-      </p:sp>
-      <p:sp>
-        <p:nvSpPr>
-          <p:cNvPr id="15" name="TextBox 14"/>
+              <a:t>–   Un índice que ninguna consulta usa es un </a:t>
+            </a:r>
+            <a:r>
+              <a:rPr sz="2000" b="1" i="0">
+                <a:solidFill>
+                  <a:srgbClr val="333333"/>
+                </a:solidFill>
+                <a:latin typeface="Calibri"/>
+              </a:rPr>
+              <a:t>hallazgo</a:t>
+            </a:r>
+            <a:r>
+              <a:rPr sz="2000" b="0" i="0">
+                <a:solidFill>
+                  <a:srgbClr val="333333"/>
+                </a:solidFill>
+                <a:latin typeface="Calibri"/>
+              </a:rPr>
+              <a:t>, no un avance.</a:t>
+            </a:r>
+          </a:p>
+        </p:txBody>
+      </p:sp>
+      <p:sp>
+        <p:nvSpPr>
+          <p:cNvPr id="20" name="TextBox 19"/>
           <p:cNvSpPr txBox="1"/>
           <p:nvPr/>
         </p:nvSpPr>
@@ -12485,6 +14079,59 @@
                       </p:childTnLst>
                     </p:cTn>
                   </p:par>
+                  <p:par>
+                    <p:cTn id="13" fill="hold">
+                      <p:stCondLst>
+                        <p:cond delay="indefinite"/>
+                      </p:stCondLst>
+                      <p:childTnLst>
+                        <p:par>
+                          <p:cTn id="14" fill="hold">
+                            <p:stCondLst>
+                              <p:cond delay="0"/>
+                            </p:stCondLst>
+                            <p:childTnLst>
+                              <p:par>
+                                <p:cTn id="15" presetID="10" presetClass="entr" presetSubtype="0" fill="hold" nodeType="clickEffect">
+                                  <p:stCondLst>
+                                    <p:cond delay="0"/>
+                                  </p:stCondLst>
+                                  <p:childTnLst>
+                                    <p:set>
+                                      <p:cBhvr>
+                                        <p:cTn id="16" dur="1" fill="hold">
+                                          <p:stCondLst>
+                                            <p:cond delay="0"/>
+                                          </p:stCondLst>
+                                        </p:cTn>
+                                        <p:tgtEl>
+                                          <p:spTgt spid="9"/>
+                                        </p:tgtEl>
+                                        <p:attrNameLst>
+                                          <p:attrName>style.visibility</p:attrName>
+                                        </p:attrNameLst>
+                                      </p:cBhvr>
+                                      <p:to>
+                                        <p:strVal val="visible"/>
+                                      </p:to>
+                                    </p:set>
+                                    <p:animEffect transition="in" filter="fade">
+                                      <p:cBhvr>
+                                        <p:cTn id="17" dur="450"/>
+                                        <p:tgtEl>
+                                          <p:spTgt spid="9"/>
+                                        </p:tgtEl>
+                                      </p:cBhvr>
+                                    </p:animEffect>
+                                  </p:childTnLst>
+                                </p:cTn>
+                              </p:par>
+                            </p:childTnLst>
+                          </p:cTn>
+                        </p:par>
+                      </p:childTnLst>
+                    </p:cTn>
+                  </p:par>
                 </p:childTnLst>
               </p:cTn>
               <p:prevCondLst>
@@ -14302,7 +15949,25 @@
                 </a:solidFill>
                 <a:latin typeface="Calibri"/>
               </a:rPr>
-              <a:t>–   Scope creep es el crecimiento no controlado del alcance: funcionalidad que se va agregando sin que nadie decida agregarla y sin que se quite nada a…</a:t>
+              <a:t>–   </a:t>
+            </a:r>
+            <a:r>
+              <a:rPr sz="2000" b="1" i="0">
+                <a:solidFill>
+                  <a:srgbClr val="333333"/>
+                </a:solidFill>
+                <a:latin typeface="Calibri"/>
+              </a:rPr>
+              <a:t>Scope creep</a:t>
+            </a:r>
+            <a:r>
+              <a:rPr sz="2000" b="0" i="0">
+                <a:solidFill>
+                  <a:srgbClr val="333333"/>
+                </a:solidFill>
+                <a:latin typeface="Calibri"/>
+              </a:rPr>
+              <a:t> es agregar funcionalidad sin que nadie lo decida y sin quitar nada a cambio.</a:t>
             </a:r>
           </a:p>
           <a:p>
@@ -14318,7 +15983,25 @@
                 </a:solidFill>
                 <a:latin typeface="Calibri"/>
               </a:rPr>
-              <a:t>–   En un proyecto de base de datos tiene un sintoma cuantificable.</a:t>
+              <a:t>–   En una base de datos se mide en </a:t>
+            </a:r>
+            <a:r>
+              <a:rPr sz="2000" b="1" i="0">
+                <a:solidFill>
+                  <a:srgbClr val="333333"/>
+                </a:solidFill>
+                <a:latin typeface="Calibri"/>
+              </a:rPr>
+              <a:t>entidades</a:t>
+            </a:r>
+            <a:r>
+              <a:rPr sz="2000" b="0" i="0">
+                <a:solidFill>
+                  <a:srgbClr val="333333"/>
+                </a:solidFill>
+                <a:latin typeface="Calibri"/>
+              </a:rPr>
+              <a:t>, y el rango sano a esta altura es de 6 a 9.</a:t>
             </a:r>
           </a:p>
           <a:p>
@@ -14334,7 +16017,59 @@
                 </a:solidFill>
                 <a:latin typeface="Calibri"/>
               </a:rPr>
-              <a:t>–   Insumo y Factura con su detalle) y el rango sano al llegar a la Clase 11 es de seis a nueve.</a:t>
+              <a:t>–   Quince entidades no es ir adelantado: es el mismo esfuerzo en el </a:t>
+            </a:r>
+            <a:r>
+              <a:rPr sz="2000" b="1" i="0">
+                <a:solidFill>
+                  <a:srgbClr val="333333"/>
+                </a:solidFill>
+                <a:latin typeface="Calibri"/>
+              </a:rPr>
+              <a:t>doble de superficie</a:t>
+            </a:r>
+            <a:r>
+              <a:rPr sz="2000" b="0" i="0">
+                <a:solidFill>
+                  <a:srgbClr val="333333"/>
+                </a:solidFill>
+                <a:latin typeface="Calibri"/>
+              </a:rPr>
+              <a:t>.</a:t>
+            </a:r>
+          </a:p>
+          <a:p>
+            <a:pPr>
+              <a:spcAft>
+                <a:spcPts val="800"/>
+              </a:spcAft>
+            </a:pPr>
+            <a:r>
+              <a:rPr sz="2000" b="0" i="0">
+                <a:solidFill>
+                  <a:srgbClr val="333333"/>
+                </a:solidFill>
+                <a:latin typeface="Calibri"/>
+              </a:rPr>
+              <a:t>–   Las que sobran pasan a </a:t>
+            </a:r>
+            <a:r>
+              <a:rPr sz="2000" b="1" i="0">
+                <a:solidFill>
+                  <a:srgbClr val="333333"/>
+                </a:solidFill>
+                <a:latin typeface="Calibri"/>
+              </a:rPr>
+              <a:t>alcance futuro</a:t>
+            </a:r>
+            <a:r>
+              <a:rPr sz="2000" b="0" i="0">
+                <a:solidFill>
+                  <a:srgbClr val="333333"/>
+                </a:solidFill>
+                <a:latin typeface="Calibri"/>
+              </a:rPr>
+              <a:t> del informe, con la razón por la que quedaron fuera.</a:t>
             </a:r>
           </a:p>
         </p:txBody>

</xml_diff>